<commit_message>
Renomme la marque "Kôji" en "Koji" partout dans l'application
Retire l'accent circonflexe sur le O dans tous les textes visibles :
logo/wordmark (page de connexion, PDF devis/facture/carte de visite),
emails (expediteur et gabarits), notifications, interface (Kôji
Signature, Kôji Particulier, etc.) et documents internes (cahier des
charges, recap manager, regeneres avec le nouveau nom).

Met aussi a jour SMTP_FROM dans .env.local et .env.example -- c'etait
la vraie source du nom affiche comme expediteur des emails, la valeur
par defaut dans lib/mailer.js ne s'appliquait jamais tant que cette
variable etait definie.

Le nom interne "koji-signature" (valeur technique non affichee,
utilisee dans les comparaisons de code) n'a pas besoin de changer,
il n'a jamais porte l'accent.

Co-Authored-By: Claude Sonnet 5 <noreply@anthropic.com>
</commit_message>
<xml_diff>
--- a/docs/cahier-des-charges/Cahier-des-charges-Koji-Web.pptx
+++ b/docs/cahier-des-charges/Cahier-des-charges-Koji-Web.pptx
@@ -8760,7 +8760,7 @@
                 <a:ea typeface="Georgia" pitchFamily="34" charset="-122"/>
                 <a:cs typeface="Georgia" pitchFamily="34" charset="-120"/>
               </a:rPr>
-              <a:t>KÔJI</a:t>
+              <a:t>KOJI</a:t>
             </a:r>
             <a:endParaRPr lang="en-US" sz="2000" dirty="0"/>
           </a:p>
@@ -8838,7 +8838,7 @@
                 <a:ea typeface="Segoe UI" pitchFamily="34" charset="-122"/>
                 <a:cs typeface="Segoe UI" pitchFamily="34" charset="-120"/>
               </a:rPr>
-              <a:t>Application Web Kôji — Gestion d'entreprise du bâtiment</a:t>
+              <a:t>Application Web Koji — Gestion d'entreprise du bâtiment</a:t>
             </a:r>
             <a:endParaRPr lang="en-US" sz="1700" dirty="0"/>
           </a:p>
@@ -8955,7 +8955,7 @@
                 <a:ea typeface="Segoe UI" pitchFamily="34" charset="-122"/>
                 <a:cs typeface="Segoe UI" pitchFamily="34" charset="-120"/>
               </a:rPr>
-              <a:t>Application Kôji Web développée par : BOUHOUCHI Amira</a:t>
+              <a:t>Application Koji Web développée par : BOUHOUCHI Amira</a:t>
             </a:r>
             <a:endParaRPr lang="en-US" sz="1200" dirty="0"/>
           </a:p>
@@ -9505,7 +9505,7 @@
                 <a:ea typeface="Segoe UI" pitchFamily="34" charset="-122"/>
                 <a:cs typeface="Segoe UI" pitchFamily="34" charset="-120"/>
               </a:rPr>
-              <a:t>Kôji Web — Cahier des charges</a:t>
+              <a:t>Koji Web — Cahier des charges</a:t>
             </a:r>
             <a:endParaRPr lang="en-US" sz="850" dirty="0"/>
           </a:p>
@@ -10094,7 +10094,7 @@
                 <a:ea typeface="Segoe UI" pitchFamily="34" charset="-122"/>
                 <a:cs typeface="Segoe UI" pitchFamily="34" charset="-120"/>
               </a:rPr>
-              <a:t>Kôji Web — Cahier des charges</a:t>
+              <a:t>Koji Web — Cahier des charges</a:t>
             </a:r>
             <a:endParaRPr lang="en-US" sz="850" dirty="0"/>
           </a:p>
@@ -10683,7 +10683,7 @@
                 <a:ea typeface="Segoe UI" pitchFamily="34" charset="-122"/>
                 <a:cs typeface="Segoe UI" pitchFamily="34" charset="-120"/>
               </a:rPr>
-              <a:t>Kôji Web — Cahier des charges</a:t>
+              <a:t>Koji Web — Cahier des charges</a:t>
             </a:r>
             <a:endParaRPr lang="en-US" sz="850" dirty="0"/>
           </a:p>
@@ -11272,7 +11272,7 @@
                 <a:ea typeface="Segoe UI" pitchFamily="34" charset="-122"/>
                 <a:cs typeface="Segoe UI" pitchFamily="34" charset="-120"/>
               </a:rPr>
-              <a:t>Kôji Web — Cahier des charges</a:t>
+              <a:t>Koji Web — Cahier des charges</a:t>
             </a:r>
             <a:endParaRPr lang="en-US" sz="850" dirty="0"/>
           </a:p>
@@ -11532,7 +11532,7 @@
                 <a:ea typeface="Segoe UI" pitchFamily="34" charset="-122"/>
                 <a:cs typeface="Segoe UI" pitchFamily="34" charset="-120"/>
               </a:rPr>
-              <a:t>Période d'essai de 14 jours ; à l'expiration, l'entreprise est redirigée vers une page présentant 3 formules (Kôji GO / Premium / Business).</a:t>
+              <a:t>Période d'essai de 14 jours ; à l'expiration, l'entreprise est redirigée vers une page présentant 3 formules (Koji GO / Premium / Business).</a:t>
             </a:r>
             <a:endParaRPr lang="en-US" sz="1150" dirty="0"/>
           </a:p>
@@ -11652,7 +11652,7 @@
                 <a:ea typeface="Segoe UI" pitchFamily="34" charset="-122"/>
                 <a:cs typeface="Segoe UI" pitchFamily="34" charset="-120"/>
               </a:rPr>
-              <a:t>Kôji Web — Cahier des charges</a:t>
+              <a:t>Koji Web — Cahier des charges</a:t>
             </a:r>
             <a:endParaRPr lang="en-US" sz="850" dirty="0"/>
           </a:p>
@@ -11902,7 +11902,7 @@
                 <a:ea typeface="Segoe UI" pitchFamily="34" charset="-122"/>
                 <a:cs typeface="Segoe UI" pitchFamily="34" charset="-120"/>
               </a:rPr>
-              <a:t>Kôji Web — Cahier des charges</a:t>
+              <a:t>Koji Web — Cahier des charges</a:t>
             </a:r>
             <a:endParaRPr lang="en-US" sz="850" dirty="0"/>
           </a:p>
@@ -12491,7 +12491,7 @@
                 <a:ea typeface="Segoe UI" pitchFamily="34" charset="-122"/>
                 <a:cs typeface="Segoe UI" pitchFamily="34" charset="-120"/>
               </a:rPr>
-              <a:t>Kôji Web — Cahier des charges</a:t>
+              <a:t>Koji Web — Cahier des charges</a:t>
             </a:r>
             <a:endParaRPr lang="en-US" sz="850" dirty="0"/>
           </a:p>
@@ -13080,7 +13080,7 @@
                 <a:ea typeface="Segoe UI" pitchFamily="34" charset="-122"/>
                 <a:cs typeface="Segoe UI" pitchFamily="34" charset="-120"/>
               </a:rPr>
-              <a:t>Kôji Web — Cahier des charges</a:t>
+              <a:t>Koji Web — Cahier des charges</a:t>
             </a:r>
             <a:endParaRPr lang="en-US" sz="850" dirty="0"/>
           </a:p>
@@ -13669,7 +13669,7 @@
                 <a:ea typeface="Segoe UI" pitchFamily="34" charset="-122"/>
                 <a:cs typeface="Segoe UI" pitchFamily="34" charset="-120"/>
               </a:rPr>
-              <a:t>Kôji Web — Cahier des charges</a:t>
+              <a:t>Koji Web — Cahier des charges</a:t>
             </a:r>
             <a:endParaRPr lang="en-US" sz="850" dirty="0"/>
           </a:p>
@@ -14258,7 +14258,7 @@
                 <a:ea typeface="Segoe UI" pitchFamily="34" charset="-122"/>
                 <a:cs typeface="Segoe UI" pitchFamily="34" charset="-120"/>
               </a:rPr>
-              <a:t>Kôji Web — Cahier des charges</a:t>
+              <a:t>Koji Web — Cahier des charges</a:t>
             </a:r>
             <a:endParaRPr lang="en-US" sz="850" dirty="0"/>
           </a:p>
@@ -14410,7 +14410,7 @@
                 <a:ea typeface="Segoe UI" pitchFamily="34" charset="-122"/>
                 <a:cs typeface="Segoe UI" pitchFamily="34" charset="-120"/>
               </a:rPr>
-              <a:t>Kôji Web est une application de gestion destinée aux entreprises du bâtiment (plomberie, électricité, climatisation, tous corps d'état) : elle couvre l'ensemble du cycle d'activité, de la création d'un devis jusqu'à la facturation, en passant par le suivi de chantier, la gestion de l'équipe et le pointage des heures. Trois profils l'utilisent : l'entreprise (gérant/administratif), le client particulier (portail de suivi) et l'ouvrier/sous-traitant (portail terrain). Ce document décrit, module par module, chaque fonctionnalité de l'application, ce qu'elle permet de faire et comment elle a été réalisée techniquement.</a:t>
+              <a:t>Koji Web est une application de gestion destinée aux entreprises du bâtiment (plomberie, électricité, climatisation, tous corps d'état) : elle couvre l'ensemble du cycle d'activité, de la création d'un devis jusqu'à la facturation, en passant par le suivi de chantier, la gestion de l'équipe et le pointage des heures. Trois profils l'utilisent : l'entreprise (gérant/administratif), le client particulier (portail de suivi) et l'ouvrier/sous-traitant (portail terrain). Ce document décrit, module par module, chaque fonctionnalité de l'application, ce qu'elle permet de faire et comment elle a été réalisée techniquement.</a:t>
             </a:r>
             <a:endParaRPr lang="en-US" sz="1200" dirty="0"/>
           </a:p>
@@ -14654,7 +14654,7 @@
                 <a:ea typeface="Segoe UI" pitchFamily="34" charset="-122"/>
                 <a:cs typeface="Segoe UI" pitchFamily="34" charset="-120"/>
               </a:rPr>
-              <a:t>Kôji Web — Cahier des charges</a:t>
+              <a:t>Koji Web — Cahier des charges</a:t>
             </a:r>
             <a:endParaRPr lang="en-US" sz="850" dirty="0"/>
           </a:p>
@@ -14904,7 +14904,7 @@
                 <a:ea typeface="Segoe UI" pitchFamily="34" charset="-122"/>
                 <a:cs typeface="Segoe UI" pitchFamily="34" charset="-120"/>
               </a:rPr>
-              <a:t>Kôji Web — Cahier des charges</a:t>
+              <a:t>Koji Web — Cahier des charges</a:t>
             </a:r>
             <a:endParaRPr lang="en-US" sz="850" dirty="0"/>
           </a:p>
@@ -15493,7 +15493,7 @@
                 <a:ea typeface="Segoe UI" pitchFamily="34" charset="-122"/>
                 <a:cs typeface="Segoe UI" pitchFamily="34" charset="-120"/>
               </a:rPr>
-              <a:t>Kôji Web — Cahier des charges</a:t>
+              <a:t>Koji Web — Cahier des charges</a:t>
             </a:r>
             <a:endParaRPr lang="en-US" sz="850" dirty="0"/>
           </a:p>
@@ -16082,7 +16082,7 @@
                 <a:ea typeface="Segoe UI" pitchFamily="34" charset="-122"/>
                 <a:cs typeface="Segoe UI" pitchFamily="34" charset="-120"/>
               </a:rPr>
-              <a:t>Kôji Web — Cahier des charges</a:t>
+              <a:t>Koji Web — Cahier des charges</a:t>
             </a:r>
             <a:endParaRPr lang="en-US" sz="850" dirty="0"/>
           </a:p>
@@ -16332,7 +16332,7 @@
                 <a:ea typeface="Segoe UI" pitchFamily="34" charset="-122"/>
                 <a:cs typeface="Segoe UI" pitchFamily="34" charset="-120"/>
               </a:rPr>
-              <a:t>Kôji Web — Cahier des charges</a:t>
+              <a:t>Koji Web — Cahier des charges</a:t>
             </a:r>
             <a:endParaRPr lang="en-US" sz="850" dirty="0"/>
           </a:p>
@@ -16921,7 +16921,7 @@
                 <a:ea typeface="Segoe UI" pitchFamily="34" charset="-122"/>
                 <a:cs typeface="Segoe UI" pitchFamily="34" charset="-120"/>
               </a:rPr>
-              <a:t>Kôji Web — Cahier des charges</a:t>
+              <a:t>Koji Web — Cahier des charges</a:t>
             </a:r>
             <a:endParaRPr lang="en-US" sz="850" dirty="0"/>
           </a:p>
@@ -17348,7 +17348,7 @@
                 <a:ea typeface="Segoe UI" pitchFamily="34" charset="-122"/>
                 <a:cs typeface="Segoe UI" pitchFamily="34" charset="-120"/>
               </a:rPr>
-              <a:t>Kôji Web — Cahier des charges</a:t>
+              <a:t>Koji Web — Cahier des charges</a:t>
             </a:r>
             <a:endParaRPr lang="en-US" sz="850" dirty="0"/>
           </a:p>
@@ -17775,7 +17775,7 @@
                 <a:ea typeface="Segoe UI" pitchFamily="34" charset="-122"/>
                 <a:cs typeface="Segoe UI" pitchFamily="34" charset="-120"/>
               </a:rPr>
-              <a:t>Kôji Web — Cahier des charges</a:t>
+              <a:t>Koji Web — Cahier des charges</a:t>
             </a:r>
             <a:endParaRPr lang="en-US" sz="850" dirty="0"/>
           </a:p>
@@ -18202,7 +18202,7 @@
                 <a:ea typeface="Segoe UI" pitchFamily="34" charset="-122"/>
                 <a:cs typeface="Segoe UI" pitchFamily="34" charset="-120"/>
               </a:rPr>
-              <a:t>Kôji Web — Cahier des charges</a:t>
+              <a:t>Koji Web — Cahier des charges</a:t>
             </a:r>
             <a:endParaRPr lang="en-US" sz="850" dirty="0"/>
           </a:p>
@@ -18629,7 +18629,7 @@
                 <a:ea typeface="Segoe UI" pitchFamily="34" charset="-122"/>
                 <a:cs typeface="Segoe UI" pitchFamily="34" charset="-120"/>
               </a:rPr>
-              <a:t>Kôji Web — Cahier des charges</a:t>
+              <a:t>Koji Web — Cahier des charges</a:t>
             </a:r>
             <a:endParaRPr lang="en-US" sz="850" dirty="0"/>
           </a:p>
@@ -18928,7 +18928,7 @@
                 <a:ea typeface="Segoe UI" pitchFamily="34" charset="-122"/>
                 <a:cs typeface="Segoe UI" pitchFamily="34" charset="-120"/>
               </a:rPr>
-              <a:t>Kôji Web — Cahier des charges</a:t>
+              <a:t>Koji Web — Cahier des charges</a:t>
             </a:r>
             <a:endParaRPr lang="en-US" sz="850" dirty="0"/>
           </a:p>
@@ -20637,7 +20637,7 @@
                 <a:ea typeface="Segoe UI" pitchFamily="34" charset="-122"/>
                 <a:cs typeface="Segoe UI" pitchFamily="34" charset="-120"/>
               </a:rPr>
-              <a:t>Kôji Web — Cahier des charges</a:t>
+              <a:t>Koji Web — Cahier des charges</a:t>
             </a:r>
             <a:endParaRPr lang="en-US" sz="850" dirty="0"/>
           </a:p>
@@ -20887,7 +20887,7 @@
                 <a:ea typeface="Segoe UI" pitchFamily="34" charset="-122"/>
                 <a:cs typeface="Segoe UI" pitchFamily="34" charset="-120"/>
               </a:rPr>
-              <a:t>Kôji Web — Cahier des charges</a:t>
+              <a:t>Koji Web — Cahier des charges</a:t>
             </a:r>
             <a:endParaRPr lang="en-US" sz="850" dirty="0"/>
           </a:p>
@@ -21395,7 +21395,7 @@
                 <a:ea typeface="Segoe UI" pitchFamily="34" charset="-122"/>
                 <a:cs typeface="Segoe UI" pitchFamily="34" charset="-120"/>
               </a:rPr>
-              <a:t>Kôji Web — Cahier des charges</a:t>
+              <a:t>Koji Web — Cahier des charges</a:t>
             </a:r>
             <a:endParaRPr lang="en-US" sz="850" dirty="0"/>
           </a:p>
@@ -21736,7 +21736,7 @@
                 <a:ea typeface="Segoe UI" pitchFamily="34" charset="-122"/>
                 <a:cs typeface="Segoe UI" pitchFamily="34" charset="-120"/>
               </a:rPr>
-              <a:t>Page publique /signature/[jeton] ; API /api/signatures/[jeton] ; accès via une clé technique dédiée (le client n'a pas de session Kôji).</a:t>
+              <a:t>Page publique /signature/[jeton] ; API /api/signatures/[jeton] ; accès via une clé technique dédiée (le client n'a pas de session Koji).</a:t>
             </a:r>
             <a:endParaRPr lang="en-US" sz="1000" dirty="0"/>
           </a:p>
@@ -21984,7 +21984,7 @@
                 <a:ea typeface="Segoe UI" pitchFamily="34" charset="-122"/>
                 <a:cs typeface="Segoe UI" pitchFamily="34" charset="-120"/>
               </a:rPr>
-              <a:t>Kôji Web — Cahier des charges</a:t>
+              <a:t>Koji Web — Cahier des charges</a:t>
             </a:r>
             <a:endParaRPr lang="en-US" sz="850" dirty="0"/>
           </a:p>
@@ -22283,7 +22283,7 @@
                 <a:ea typeface="Segoe UI" pitchFamily="34" charset="-122"/>
                 <a:cs typeface="Segoe UI" pitchFamily="34" charset="-120"/>
               </a:rPr>
-              <a:t>Kôji Web — Cahier des charges</a:t>
+              <a:t>Koji Web — Cahier des charges</a:t>
             </a:r>
             <a:endParaRPr lang="en-US" sz="850" dirty="0"/>
           </a:p>
@@ -22533,7 +22533,7 @@
                 <a:ea typeface="Segoe UI" pitchFamily="34" charset="-122"/>
                 <a:cs typeface="Segoe UI" pitchFamily="34" charset="-120"/>
               </a:rPr>
-              <a:t>Kôji Web — Cahier des charges</a:t>
+              <a:t>Koji Web — Cahier des charges</a:t>
             </a:r>
             <a:endParaRPr lang="en-US" sz="850" dirty="0"/>
           </a:p>
@@ -23041,7 +23041,7 @@
                 <a:ea typeface="Segoe UI" pitchFamily="34" charset="-122"/>
                 <a:cs typeface="Segoe UI" pitchFamily="34" charset="-120"/>
               </a:rPr>
-              <a:t>Kôji Web — Cahier des charges</a:t>
+              <a:t>Koji Web — Cahier des charges</a:t>
             </a:r>
             <a:endParaRPr lang="en-US" sz="850" dirty="0"/>
           </a:p>
@@ -23468,7 +23468,7 @@
                 <a:ea typeface="Segoe UI" pitchFamily="34" charset="-122"/>
                 <a:cs typeface="Segoe UI" pitchFamily="34" charset="-120"/>
               </a:rPr>
-              <a:t>Kôji Web — Cahier des charges</a:t>
+              <a:t>Koji Web — Cahier des charges</a:t>
             </a:r>
             <a:endParaRPr lang="en-US" sz="850" dirty="0"/>
           </a:p>
@@ -23895,7 +23895,7 @@
                 <a:ea typeface="Segoe UI" pitchFamily="34" charset="-122"/>
                 <a:cs typeface="Segoe UI" pitchFamily="34" charset="-120"/>
               </a:rPr>
-              <a:t>Kôji Web — Cahier des charges</a:t>
+              <a:t>Koji Web — Cahier des charges</a:t>
             </a:r>
             <a:endParaRPr lang="en-US" sz="850" dirty="0"/>
           </a:p>
@@ -24322,7 +24322,7 @@
                 <a:ea typeface="Segoe UI" pitchFamily="34" charset="-122"/>
                 <a:cs typeface="Segoe UI" pitchFamily="34" charset="-120"/>
               </a:rPr>
-              <a:t>Kôji Web — Cahier des charges</a:t>
+              <a:t>Koji Web — Cahier des charges</a:t>
             </a:r>
             <a:endParaRPr lang="en-US" sz="850" dirty="0"/>
           </a:p>
@@ -24749,7 +24749,7 @@
                 <a:ea typeface="Segoe UI" pitchFamily="34" charset="-122"/>
                 <a:cs typeface="Segoe UI" pitchFamily="34" charset="-120"/>
               </a:rPr>
-              <a:t>Kôji Web — Cahier des charges</a:t>
+              <a:t>Koji Web — Cahier des charges</a:t>
             </a:r>
             <a:endParaRPr lang="en-US" sz="850" dirty="0"/>
           </a:p>
@@ -24960,7 +24960,7 @@
                 <a:ea typeface="Segoe UI" pitchFamily="34" charset="-122"/>
                 <a:cs typeface="Segoe UI" pitchFamily="34" charset="-120"/>
               </a:rPr>
-              <a:t>Vue d'ensemble des langages, frameworks et services utilisés pour construire et faire fonctionner Kôji Web.</a:t>
+              <a:t>Vue d'ensemble des langages, frameworks et services utilisés pour construire et faire fonctionner Koji Web.</a:t>
             </a:r>
             <a:endParaRPr lang="en-US" sz="1300" dirty="0"/>
           </a:p>
@@ -24999,7 +24999,7 @@
                 <a:ea typeface="Segoe UI" pitchFamily="34" charset="-122"/>
                 <a:cs typeface="Segoe UI" pitchFamily="34" charset="-120"/>
               </a:rPr>
-              <a:t>Kôji Web — Cahier des charges</a:t>
+              <a:t>Koji Web — Cahier des charges</a:t>
             </a:r>
             <a:endParaRPr lang="en-US" sz="850" dirty="0"/>
           </a:p>
@@ -25249,7 +25249,7 @@
                 <a:ea typeface="Segoe UI" pitchFamily="34" charset="-122"/>
                 <a:cs typeface="Segoe UI" pitchFamily="34" charset="-120"/>
               </a:rPr>
-              <a:t>Kôji Web — Cahier des charges</a:t>
+              <a:t>Koji Web — Cahier des charges</a:t>
             </a:r>
             <a:endParaRPr lang="en-US" sz="850" dirty="0"/>
           </a:p>
@@ -25757,7 +25757,7 @@
                 <a:ea typeface="Segoe UI" pitchFamily="34" charset="-122"/>
                 <a:cs typeface="Segoe UI" pitchFamily="34" charset="-120"/>
               </a:rPr>
-              <a:t>Kôji Web — Cahier des charges</a:t>
+              <a:t>Koji Web — Cahier des charges</a:t>
             </a:r>
             <a:endParaRPr lang="en-US" sz="850" dirty="0"/>
           </a:p>
@@ -26265,7 +26265,7 @@
                 <a:ea typeface="Segoe UI" pitchFamily="34" charset="-122"/>
                 <a:cs typeface="Segoe UI" pitchFamily="34" charset="-120"/>
               </a:rPr>
-              <a:t>Kôji Web — Cahier des charges</a:t>
+              <a:t>Koji Web — Cahier des charges</a:t>
             </a:r>
             <a:endParaRPr lang="en-US" sz="850" dirty="0"/>
           </a:p>
@@ -26692,7 +26692,7 @@
                 <a:ea typeface="Segoe UI" pitchFamily="34" charset="-122"/>
                 <a:cs typeface="Segoe UI" pitchFamily="34" charset="-120"/>
               </a:rPr>
-              <a:t>Kôji Web — Cahier des charges</a:t>
+              <a:t>Koji Web — Cahier des charges</a:t>
             </a:r>
             <a:endParaRPr lang="en-US" sz="850" dirty="0"/>
           </a:p>
@@ -26991,7 +26991,7 @@
                 <a:ea typeface="Segoe UI" pitchFamily="34" charset="-122"/>
                 <a:cs typeface="Segoe UI" pitchFamily="34" charset="-120"/>
               </a:rPr>
-              <a:t>Kôji Web — Cahier des charges</a:t>
+              <a:t>Koji Web — Cahier des charges</a:t>
             </a:r>
             <a:endParaRPr lang="en-US" sz="850" dirty="0"/>
           </a:p>
@@ -27241,7 +27241,7 @@
                 <a:ea typeface="Segoe UI" pitchFamily="34" charset="-122"/>
                 <a:cs typeface="Segoe UI" pitchFamily="34" charset="-120"/>
               </a:rPr>
-              <a:t>Kôji Web — Cahier des charges</a:t>
+              <a:t>Koji Web — Cahier des charges</a:t>
             </a:r>
             <a:endParaRPr lang="en-US" sz="850" dirty="0"/>
           </a:p>
@@ -27830,7 +27830,7 @@
                 <a:ea typeface="Segoe UI" pitchFamily="34" charset="-122"/>
                 <a:cs typeface="Segoe UI" pitchFamily="34" charset="-120"/>
               </a:rPr>
-              <a:t>Kôji Web — Cahier des charges</a:t>
+              <a:t>Koji Web — Cahier des charges</a:t>
             </a:r>
             <a:endParaRPr lang="en-US" sz="850" dirty="0"/>
           </a:p>
@@ -28129,7 +28129,7 @@
                 <a:ea typeface="Segoe UI" pitchFamily="34" charset="-122"/>
                 <a:cs typeface="Segoe UI" pitchFamily="34" charset="-120"/>
               </a:rPr>
-              <a:t>Kôji Web — Cahier des charges</a:t>
+              <a:t>Koji Web — Cahier des charges</a:t>
             </a:r>
             <a:endParaRPr lang="en-US" sz="850" dirty="0"/>
           </a:p>
@@ -28379,7 +28379,7 @@
                 <a:ea typeface="Segoe UI" pitchFamily="34" charset="-122"/>
                 <a:cs typeface="Segoe UI" pitchFamily="34" charset="-120"/>
               </a:rPr>
-              <a:t>Kôji Web — Cahier des charges</a:t>
+              <a:t>Koji Web — Cahier des charges</a:t>
             </a:r>
             <a:endParaRPr lang="en-US" sz="850" dirty="0"/>
           </a:p>
@@ -28968,7 +28968,7 @@
                 <a:ea typeface="Segoe UI" pitchFamily="34" charset="-122"/>
                 <a:cs typeface="Segoe UI" pitchFamily="34" charset="-120"/>
               </a:rPr>
-              <a:t>Kôji Web — Cahier des charges</a:t>
+              <a:t>Koji Web — Cahier des charges</a:t>
             </a:r>
             <a:endParaRPr lang="en-US" sz="850" dirty="0"/>
           </a:p>
@@ -29557,7 +29557,7 @@
                 <a:ea typeface="Segoe UI" pitchFamily="34" charset="-122"/>
                 <a:cs typeface="Segoe UI" pitchFamily="34" charset="-120"/>
               </a:rPr>
-              <a:t>Kôji Web — Cahier des charges</a:t>
+              <a:t>Koji Web — Cahier des charges</a:t>
             </a:r>
             <a:endParaRPr lang="en-US" sz="850" dirty="0"/>
           </a:p>
@@ -29984,7 +29984,7 @@
                 <a:ea typeface="Segoe UI" pitchFamily="34" charset="-122"/>
                 <a:cs typeface="Segoe UI" pitchFamily="34" charset="-120"/>
               </a:rPr>
-              <a:t>Kôji Web — Cahier des charges</a:t>
+              <a:t>Koji Web — Cahier des charges</a:t>
             </a:r>
             <a:endParaRPr lang="en-US" sz="850" dirty="0"/>
           </a:p>
@@ -30234,7 +30234,7 @@
                 <a:ea typeface="Segoe UI" pitchFamily="34" charset="-122"/>
                 <a:cs typeface="Segoe UI" pitchFamily="34" charset="-120"/>
               </a:rPr>
-              <a:t>Kôji Web — Cahier des charges</a:t>
+              <a:t>Koji Web — Cahier des charges</a:t>
             </a:r>
             <a:endParaRPr lang="en-US" sz="850" dirty="0"/>
           </a:p>
@@ -30742,7 +30742,7 @@
                 <a:ea typeface="Segoe UI" pitchFamily="34" charset="-122"/>
                 <a:cs typeface="Segoe UI" pitchFamily="34" charset="-120"/>
               </a:rPr>
-              <a:t>Kôji Web — Cahier des charges</a:t>
+              <a:t>Koji Web — Cahier des charges</a:t>
             </a:r>
             <a:endParaRPr lang="en-US" sz="850" dirty="0"/>
           </a:p>
@@ -31169,7 +31169,7 @@
                 <a:ea typeface="Segoe UI" pitchFamily="34" charset="-122"/>
                 <a:cs typeface="Segoe UI" pitchFamily="34" charset="-120"/>
               </a:rPr>
-              <a:t>Kôji Web — Cahier des charges</a:t>
+              <a:t>Koji Web — Cahier des charges</a:t>
             </a:r>
             <a:endParaRPr lang="en-US" sz="850" dirty="0"/>
           </a:p>
@@ -31468,7 +31468,7 @@
                 <a:ea typeface="Segoe UI" pitchFamily="34" charset="-122"/>
                 <a:cs typeface="Segoe UI" pitchFamily="34" charset="-120"/>
               </a:rPr>
-              <a:t>Kôji Web — Cahier des charges</a:t>
+              <a:t>Koji Web — Cahier des charges</a:t>
             </a:r>
             <a:endParaRPr lang="en-US" sz="850" dirty="0"/>
           </a:p>
@@ -31718,7 +31718,7 @@
                 <a:ea typeface="Segoe UI" pitchFamily="34" charset="-122"/>
                 <a:cs typeface="Segoe UI" pitchFamily="34" charset="-120"/>
               </a:rPr>
-              <a:t>Kôji Web — Cahier des charges</a:t>
+              <a:t>Koji Web — Cahier des charges</a:t>
             </a:r>
             <a:endParaRPr lang="en-US" sz="850" dirty="0"/>
           </a:p>
@@ -32226,7 +32226,7 @@
                 <a:ea typeface="Segoe UI" pitchFamily="34" charset="-122"/>
                 <a:cs typeface="Segoe UI" pitchFamily="34" charset="-120"/>
               </a:rPr>
-              <a:t>Kôji Web — Cahier des charges</a:t>
+              <a:t>Koji Web — Cahier des charges</a:t>
             </a:r>
             <a:endParaRPr lang="en-US" sz="850" dirty="0"/>
           </a:p>
@@ -32653,7 +32653,7 @@
                 <a:ea typeface="Segoe UI" pitchFamily="34" charset="-122"/>
                 <a:cs typeface="Segoe UI" pitchFamily="34" charset="-120"/>
               </a:rPr>
-              <a:t>Kôji Web — Cahier des charges</a:t>
+              <a:t>Koji Web — Cahier des charges</a:t>
             </a:r>
             <a:endParaRPr lang="en-US" sz="850" dirty="0"/>
           </a:p>
@@ -33080,7 +33080,7 @@
                 <a:ea typeface="Segoe UI" pitchFamily="34" charset="-122"/>
                 <a:cs typeface="Segoe UI" pitchFamily="34" charset="-120"/>
               </a:rPr>
-              <a:t>Kôji Web — Cahier des charges</a:t>
+              <a:t>Koji Web — Cahier des charges</a:t>
             </a:r>
             <a:endParaRPr lang="en-US" sz="850" dirty="0"/>
           </a:p>
@@ -33507,7 +33507,7 @@
                 <a:ea typeface="Segoe UI" pitchFamily="34" charset="-122"/>
                 <a:cs typeface="Segoe UI" pitchFamily="34" charset="-120"/>
               </a:rPr>
-              <a:t>Kôji Web — Cahier des charges</a:t>
+              <a:t>Koji Web — Cahier des charges</a:t>
             </a:r>
             <a:endParaRPr lang="en-US" sz="850" dirty="0"/>
           </a:p>
@@ -34096,7 +34096,7 @@
                 <a:ea typeface="Segoe UI" pitchFamily="34" charset="-122"/>
                 <a:cs typeface="Segoe UI" pitchFamily="34" charset="-120"/>
               </a:rPr>
-              <a:t>Kôji Web — Cahier des charges</a:t>
+              <a:t>Koji Web — Cahier des charges</a:t>
             </a:r>
             <a:endParaRPr lang="en-US" sz="850" dirty="0"/>
           </a:p>
@@ -34395,7 +34395,7 @@
                 <a:ea typeface="Segoe UI" pitchFamily="34" charset="-122"/>
                 <a:cs typeface="Segoe UI" pitchFamily="34" charset="-120"/>
               </a:rPr>
-              <a:t>Kôji Web — Cahier des charges</a:t>
+              <a:t>Koji Web — Cahier des charges</a:t>
             </a:r>
             <a:endParaRPr lang="en-US" sz="850" dirty="0"/>
           </a:p>
@@ -34645,7 +34645,7 @@
                 <a:ea typeface="Segoe UI" pitchFamily="34" charset="-122"/>
                 <a:cs typeface="Segoe UI" pitchFamily="34" charset="-120"/>
               </a:rPr>
-              <a:t>Kôji Web — Cahier des charges</a:t>
+              <a:t>Koji Web — Cahier des charges</a:t>
             </a:r>
             <a:endParaRPr lang="en-US" sz="850" dirty="0"/>
           </a:p>
@@ -35153,7 +35153,7 @@
                 <a:ea typeface="Segoe UI" pitchFamily="34" charset="-122"/>
                 <a:cs typeface="Segoe UI" pitchFamily="34" charset="-120"/>
               </a:rPr>
-              <a:t>Kôji Web — Cahier des charges</a:t>
+              <a:t>Koji Web — Cahier des charges</a:t>
             </a:r>
             <a:endParaRPr lang="en-US" sz="850" dirty="0"/>
           </a:p>
@@ -35580,7 +35580,7 @@
                 <a:ea typeface="Segoe UI" pitchFamily="34" charset="-122"/>
                 <a:cs typeface="Segoe UI" pitchFamily="34" charset="-120"/>
               </a:rPr>
-              <a:t>Kôji Web — Cahier des charges</a:t>
+              <a:t>Koji Web — Cahier des charges</a:t>
             </a:r>
             <a:endParaRPr lang="en-US" sz="850" dirty="0"/>
           </a:p>
@@ -35830,7 +35830,7 @@
                 <a:ea typeface="Segoe UI" pitchFamily="34" charset="-122"/>
                 <a:cs typeface="Segoe UI" pitchFamily="34" charset="-120"/>
               </a:rPr>
-              <a:t>Kôji Web — Cahier des charges</a:t>
+              <a:t>Koji Web — Cahier des charges</a:t>
             </a:r>
             <a:endParaRPr lang="en-US" sz="850" dirty="0"/>
           </a:p>
@@ -36338,7 +36338,7 @@
                 <a:ea typeface="Segoe UI" pitchFamily="34" charset="-122"/>
                 <a:cs typeface="Segoe UI" pitchFamily="34" charset="-120"/>
               </a:rPr>
-              <a:t>Kôji Web — Cahier des charges</a:t>
+              <a:t>Koji Web — Cahier des charges</a:t>
             </a:r>
             <a:endParaRPr lang="en-US" sz="850" dirty="0"/>
           </a:p>
@@ -36637,7 +36637,7 @@
                 <a:ea typeface="Segoe UI" pitchFamily="34" charset="-122"/>
                 <a:cs typeface="Segoe UI" pitchFamily="34" charset="-120"/>
               </a:rPr>
-              <a:t>Kôji Web — Cahier des charges</a:t>
+              <a:t>Koji Web — Cahier des charges</a:t>
             </a:r>
             <a:endParaRPr lang="en-US" sz="850" dirty="0"/>
           </a:p>
@@ -36887,7 +36887,7 @@
                 <a:ea typeface="Segoe UI" pitchFamily="34" charset="-122"/>
                 <a:cs typeface="Segoe UI" pitchFamily="34" charset="-120"/>
               </a:rPr>
-              <a:t>Kôji Web — Cahier des charges</a:t>
+              <a:t>Koji Web — Cahier des charges</a:t>
             </a:r>
             <a:endParaRPr lang="en-US" sz="850" dirty="0"/>
           </a:p>
@@ -37476,7 +37476,7 @@
                 <a:ea typeface="Segoe UI" pitchFamily="34" charset="-122"/>
                 <a:cs typeface="Segoe UI" pitchFamily="34" charset="-120"/>
               </a:rPr>
-              <a:t>Kôji Web — Cahier des charges</a:t>
+              <a:t>Koji Web — Cahier des charges</a:t>
             </a:r>
             <a:endParaRPr lang="en-US" sz="850" dirty="0"/>
           </a:p>
@@ -37984,7 +37984,7 @@
                 <a:ea typeface="Segoe UI" pitchFamily="34" charset="-122"/>
                 <a:cs typeface="Segoe UI" pitchFamily="34" charset="-120"/>
               </a:rPr>
-              <a:t>Kôji Web — Cahier des charges</a:t>
+              <a:t>Koji Web — Cahier des charges</a:t>
             </a:r>
             <a:endParaRPr lang="en-US" sz="850" dirty="0"/>
           </a:p>
@@ -38573,7 +38573,7 @@
                 <a:ea typeface="Segoe UI" pitchFamily="34" charset="-122"/>
                 <a:cs typeface="Segoe UI" pitchFamily="34" charset="-120"/>
               </a:rPr>
-              <a:t>Kôji Web — Cahier des charges</a:t>
+              <a:t>Koji Web — Cahier des charges</a:t>
             </a:r>
             <a:endParaRPr lang="en-US" sz="850" dirty="0"/>
           </a:p>
@@ -39000,7 +39000,7 @@
                 <a:ea typeface="Segoe UI" pitchFamily="34" charset="-122"/>
                 <a:cs typeface="Segoe UI" pitchFamily="34" charset="-120"/>
               </a:rPr>
-              <a:t>Kôji Web — Cahier des charges</a:t>
+              <a:t>Koji Web — Cahier des charges</a:t>
             </a:r>
             <a:endParaRPr lang="en-US" sz="850" dirty="0"/>
           </a:p>
@@ -39380,7 +39380,7 @@
                 <a:ea typeface="Segoe UI" pitchFamily="34" charset="-122"/>
                 <a:cs typeface="Segoe UI" pitchFamily="34" charset="-120"/>
               </a:rPr>
-              <a:t>Kôji Web — Cahier des charges</a:t>
+              <a:t>Koji Web — Cahier des charges</a:t>
             </a:r>
             <a:endParaRPr lang="en-US" sz="850" dirty="0"/>
           </a:p>
@@ -39630,7 +39630,7 @@
                 <a:ea typeface="Segoe UI" pitchFamily="34" charset="-122"/>
                 <a:cs typeface="Segoe UI" pitchFamily="34" charset="-120"/>
               </a:rPr>
-              <a:t>Kôji Web — Cahier des charges</a:t>
+              <a:t>Koji Web — Cahier des charges</a:t>
             </a:r>
             <a:endParaRPr lang="en-US" sz="850" dirty="0"/>
           </a:p>
@@ -40219,7 +40219,7 @@
                 <a:ea typeface="Segoe UI" pitchFamily="34" charset="-122"/>
                 <a:cs typeface="Segoe UI" pitchFamily="34" charset="-120"/>
               </a:rPr>
-              <a:t>Kôji Web — Cahier des charges</a:t>
+              <a:t>Koji Web — Cahier des charges</a:t>
             </a:r>
             <a:endParaRPr lang="en-US" sz="850" dirty="0"/>
           </a:p>
@@ -40646,7 +40646,7 @@
                 <a:ea typeface="Segoe UI" pitchFamily="34" charset="-122"/>
                 <a:cs typeface="Segoe UI" pitchFamily="34" charset="-120"/>
               </a:rPr>
-              <a:t>Kôji Web — Cahier des charges</a:t>
+              <a:t>Koji Web — Cahier des charges</a:t>
             </a:r>
             <a:endParaRPr lang="en-US" sz="850" dirty="0"/>
           </a:p>
@@ -41073,7 +41073,7 @@
                 <a:ea typeface="Segoe UI" pitchFamily="34" charset="-122"/>
                 <a:cs typeface="Segoe UI" pitchFamily="34" charset="-120"/>
               </a:rPr>
-              <a:t>Kôji Web — Cahier des charges</a:t>
+              <a:t>Koji Web — Cahier des charges</a:t>
             </a:r>
             <a:endParaRPr lang="en-US" sz="850" dirty="0"/>
           </a:p>
@@ -41372,7 +41372,7 @@
                 <a:ea typeface="Segoe UI" pitchFamily="34" charset="-122"/>
                 <a:cs typeface="Segoe UI" pitchFamily="34" charset="-120"/>
               </a:rPr>
-              <a:t>Kôji Web — Cahier des charges</a:t>
+              <a:t>Koji Web — Cahier des charges</a:t>
             </a:r>
             <a:endParaRPr lang="en-US" sz="850" dirty="0"/>
           </a:p>
@@ -41622,7 +41622,7 @@
                 <a:ea typeface="Segoe UI" pitchFamily="34" charset="-122"/>
                 <a:cs typeface="Segoe UI" pitchFamily="34" charset="-120"/>
               </a:rPr>
-              <a:t>Kôji Web — Cahier des charges</a:t>
+              <a:t>Koji Web — Cahier des charges</a:t>
             </a:r>
             <a:endParaRPr lang="en-US" sz="850" dirty="0"/>
           </a:p>
@@ -42130,7 +42130,7 @@
                 <a:ea typeface="Segoe UI" pitchFamily="34" charset="-122"/>
                 <a:cs typeface="Segoe UI" pitchFamily="34" charset="-120"/>
               </a:rPr>
-              <a:t>Kôji Web — Cahier des charges</a:t>
+              <a:t>Koji Web — Cahier des charges</a:t>
             </a:r>
             <a:endParaRPr lang="en-US" sz="850" dirty="0"/>
           </a:p>
@@ -42557,7 +42557,7 @@
                 <a:ea typeface="Segoe UI" pitchFamily="34" charset="-122"/>
                 <a:cs typeface="Segoe UI" pitchFamily="34" charset="-120"/>
               </a:rPr>
-              <a:t>Kôji Web — Cahier des charges</a:t>
+              <a:t>Koji Web — Cahier des charges</a:t>
             </a:r>
             <a:endParaRPr lang="en-US" sz="850" dirty="0"/>
           </a:p>
@@ -43146,7 +43146,7 @@
                 <a:ea typeface="Segoe UI" pitchFamily="34" charset="-122"/>
                 <a:cs typeface="Segoe UI" pitchFamily="34" charset="-120"/>
               </a:rPr>
-              <a:t>Kôji Web — Cahier des charges</a:t>
+              <a:t>Koji Web — Cahier des charges</a:t>
             </a:r>
             <a:endParaRPr lang="en-US" sz="850" dirty="0"/>
           </a:p>
@@ -43445,7 +43445,7 @@
                 <a:ea typeface="Segoe UI" pitchFamily="34" charset="-122"/>
                 <a:cs typeface="Segoe UI" pitchFamily="34" charset="-120"/>
               </a:rPr>
-              <a:t>Kôji Web — Cahier des charges</a:t>
+              <a:t>Koji Web — Cahier des charges</a:t>
             </a:r>
             <a:endParaRPr lang="en-US" sz="850" dirty="0"/>
           </a:p>
@@ -43695,7 +43695,7 @@
                 <a:ea typeface="Segoe UI" pitchFamily="34" charset="-122"/>
                 <a:cs typeface="Segoe UI" pitchFamily="34" charset="-120"/>
               </a:rPr>
-              <a:t>Kôji Web — Cahier des charges</a:t>
+              <a:t>Koji Web — Cahier des charges</a:t>
             </a:r>
             <a:endParaRPr lang="en-US" sz="850" dirty="0"/>
           </a:p>
@@ -43955,7 +43955,7 @@
                 <a:ea typeface="Segoe UI" pitchFamily="34" charset="-122"/>
                 <a:cs typeface="Segoe UI" pitchFamily="34" charset="-120"/>
               </a:rPr>
-              <a:t>Trois formules (Kôji GO, Premium, Business) présentées avec leur liste de fonctionnalités.</a:t>
+              <a:t>Trois formules (Koji GO, Premium, Business) présentées avec leur liste de fonctionnalités.</a:t>
             </a:r>
             <a:endParaRPr lang="en-US" sz="1150" dirty="0"/>
           </a:p>
@@ -44203,7 +44203,7 @@
                 <a:ea typeface="Segoe UI" pitchFamily="34" charset="-122"/>
                 <a:cs typeface="Segoe UI" pitchFamily="34" charset="-120"/>
               </a:rPr>
-              <a:t>Kôji Web — Cahier des charges</a:t>
+              <a:t>Koji Web — Cahier des charges</a:t>
             </a:r>
             <a:endParaRPr lang="en-US" sz="850" dirty="0"/>
           </a:p>
@@ -44453,7 +44453,7 @@
                 <a:ea typeface="Segoe UI" pitchFamily="34" charset="-122"/>
                 <a:cs typeface="Segoe UI" pitchFamily="34" charset="-120"/>
               </a:rPr>
-              <a:t>Kôji Web — Cahier des charges</a:t>
+              <a:t>Koji Web — Cahier des charges</a:t>
             </a:r>
             <a:endParaRPr lang="en-US" sz="850" dirty="0"/>
           </a:p>
@@ -44752,7 +44752,7 @@
                 <a:ea typeface="Segoe UI" pitchFamily="34" charset="-122"/>
                 <a:cs typeface="Segoe UI" pitchFamily="34" charset="-120"/>
               </a:rPr>
-              <a:t>Kôji Web — Cahier des charges</a:t>
+              <a:t>Koji Web — Cahier des charges</a:t>
             </a:r>
             <a:endParaRPr lang="en-US" sz="850" dirty="0"/>
           </a:p>
@@ -45002,7 +45002,7 @@
                 <a:ea typeface="Segoe UI" pitchFamily="34" charset="-122"/>
                 <a:cs typeface="Segoe UI" pitchFamily="34" charset="-120"/>
               </a:rPr>
-              <a:t>Kôji Web — Cahier des charges</a:t>
+              <a:t>Koji Web — Cahier des charges</a:t>
             </a:r>
             <a:endParaRPr lang="en-US" sz="850" dirty="0"/>
           </a:p>
@@ -45390,7 +45390,7 @@
                 <a:ea typeface="Segoe UI" pitchFamily="34" charset="-122"/>
                 <a:cs typeface="Segoe UI" pitchFamily="34" charset="-120"/>
               </a:rPr>
-              <a:t>Les devis, chantiers et comptes sont stockés dans une base commune avec l'application mobile Kôji, pour que les deux applications restent synchronisées.</a:t>
+              <a:t>Les devis, chantiers et comptes sont stockés dans une base commune avec l'application mobile Koji, pour que les deux applications restent synchronisées.</a:t>
             </a:r>
             <a:endParaRPr lang="en-US" sz="1150" dirty="0"/>
           </a:p>
@@ -45429,7 +45429,7 @@
                 <a:ea typeface="Segoe UI" pitchFamily="34" charset="-122"/>
                 <a:cs typeface="Segoe UI" pitchFamily="34" charset="-120"/>
               </a:rPr>
-              <a:t>Kôji Web — Cahier des charges</a:t>
+              <a:t>Koji Web — Cahier des charges</a:t>
             </a:r>
             <a:endParaRPr lang="en-US" sz="850" dirty="0"/>
           </a:p>
@@ -45856,7 +45856,7 @@
                 <a:ea typeface="Segoe UI" pitchFamily="34" charset="-122"/>
                 <a:cs typeface="Segoe UI" pitchFamily="34" charset="-120"/>
               </a:rPr>
-              <a:t>Kôji Web — Cahier des charges</a:t>
+              <a:t>Koji Web — Cahier des charges</a:t>
             </a:r>
             <a:endParaRPr lang="en-US" sz="850" dirty="0"/>
           </a:p>
@@ -46155,7 +46155,7 @@
                 <a:ea typeface="Segoe UI" pitchFamily="34" charset="-122"/>
                 <a:cs typeface="Segoe UI" pitchFamily="34" charset="-120"/>
               </a:rPr>
-              <a:t>Kôji Web — Cahier des charges</a:t>
+              <a:t>Koji Web — Cahier des charges</a:t>
             </a:r>
             <a:endParaRPr lang="en-US" sz="850" dirty="0"/>
           </a:p>
@@ -46307,7 +46307,7 @@
                 <a:ea typeface="Segoe UI" pitchFamily="34" charset="-122"/>
                 <a:cs typeface="Segoe UI" pitchFamily="34" charset="-120"/>
               </a:rPr>
-              <a:t>Ce document liste l'ensemble des fonctionnalités de l'application Kôji Web telles que développées à ce jour. Il est mis à jour à chaque évolution notable de l'application.</a:t>
+              <a:t>Ce document liste l'ensemble des fonctionnalités de l'application Koji Web telles que développées à ce jour. Il est mis à jour à chaque évolution notable de l'application.</a:t>
             </a:r>
             <a:endParaRPr lang="en-US" sz="1300" dirty="0"/>
           </a:p>
@@ -46385,7 +46385,7 @@
                 <a:ea typeface="Segoe UI" pitchFamily="34" charset="-122"/>
                 <a:cs typeface="Segoe UI" pitchFamily="34" charset="-120"/>
               </a:rPr>
-              <a:t>Application Kôji Web développée par : BOUHOUCHI Amira</a:t>
+              <a:t>Application Koji Web développée par : BOUHOUCHI Amira</a:t>
             </a:r>
             <a:endParaRPr lang="en-US" sz="1200" dirty="0"/>
           </a:p>
@@ -46596,7 +46596,7 @@
                 <a:ea typeface="Segoe UI" pitchFamily="34" charset="-122"/>
                 <a:cs typeface="Segoe UI" pitchFamily="34" charset="-120"/>
               </a:rPr>
-              <a:t>Kôji Web — Cahier des charges</a:t>
+              <a:t>Koji Web — Cahier des charges</a:t>
             </a:r>
             <a:endParaRPr lang="en-US" sz="850" dirty="0"/>
           </a:p>

</xml_diff>

<commit_message>
docs: mettre à jour le cahier des charges et le recap avec la refonte Koji Pro
Ajout d'une nouvelle section "Évolutions récentes" dans le cahier des charges documentant:
- Refonte intégrale du dashboard entreprise (50 pages web)
- Refonte intégrale de l'app mobile entreprise (5 fichiers Flutter)
- Validation et tests de la refonte Koji Pro

Régénération des fichiers PPTX (manager-recap et cahier-des-charges) avec les nouvelles données.
Co-Authored-By: Claude Haiku 4.5 <noreply@anthropic.com>
</commit_message>
<xml_diff>
--- a/docs/cahier-des-charges/Cahier-des-charges-Koji-Web.pptx
+++ b/docs/cahier-des-charges/Cahier-des-charges-Koji-Web.pptx
@@ -96,9 +96,12 @@
     <p:sldId id="344" r:id="rId90"/>
     <p:sldId id="345" r:id="rId91"/>
     <p:sldId id="346" r:id="rId92"/>
+    <p:sldId id="347" r:id="rId93"/>
+    <p:sldId id="348" r:id="rId94"/>
+    <p:sldId id="349" r:id="rId95"/>
   </p:sldIdLst>
   <p:notesMasterIdLst>
-    <p:notesMasterId r:id="rId93"/>
+    <p:notesMasterId r:id="rId96"/>
   </p:notesMasterIdLst>
   <p:sldSz cx="12191695" cy="6858000"/>
   <p:notesSz cx="6858000" cy="12191695"/>
@@ -8536,6 +8539,270 @@
             <a:fld id="{F7021451-1387-4CA6-816F-3879F97B5CBC}" type="slidenum">
               <a:rPr lang="en-US"/>
               <a:t>91</a:t>
+            </a:fld>
+            <a:endParaRPr lang="en-US"/>
+          </a:p>
+        </p:txBody>
+      </p:sp>
+    </p:spTree>
+    <p:extLst>
+      <p:ext uri="{BB962C8B-B14F-4D97-AF65-F5344CB8AC3E}">
+        <p14:creationId xmlns:p14="http://schemas.microsoft.com/office/powerpoint/2010/main" val="1024086991"/>
+      </p:ext>
+    </p:extLst>
+  </p:cSld>
+  <p:clrMapOvr>
+    <a:masterClrMapping/>
+  </p:clrMapOvr>
+</p:notes>
+</file>
+
+<file path=ppt/notesSlides/notesSlide92.xml><?xml version="1.0" encoding="utf-8"?>
+<p:notes xmlns:a="http://schemas.openxmlformats.org/drawingml/2006/main" xmlns:r="http://schemas.openxmlformats.org/officeDocument/2006/relationships" xmlns:p="http://schemas.openxmlformats.org/presentationml/2006/main">
+  <p:cSld>
+    <p:spTree>
+      <p:nvGrpSpPr>
+        <p:cNvPr id="1" name=""/>
+        <p:cNvGrpSpPr/>
+        <p:nvPr/>
+      </p:nvGrpSpPr>
+      <p:grpSpPr>
+        <a:xfrm>
+          <a:off x="0" y="0"/>
+          <a:ext cx="0" cy="0"/>
+          <a:chOff x="0" y="0"/>
+          <a:chExt cx="0" cy="0"/>
+        </a:xfrm>
+      </p:grpSpPr>
+      <p:sp>
+        <p:nvSpPr>
+          <p:cNvPr id="2" name="Slide Image Placeholder 1"/>
+          <p:cNvSpPr>
+            <a:spLocks noGrp="1" noRot="1" noChangeAspect="1"/>
+          </p:cNvSpPr>
+          <p:nvPr>
+            <p:ph type="sldImg"/>
+          </p:nvPr>
+        </p:nvSpPr>
+        <p:spPr/>
+      </p:sp>
+      <p:sp>
+        <p:nvSpPr>
+          <p:cNvPr id="3" name="Notes Placeholder 2"/>
+          <p:cNvSpPr>
+            <a:spLocks noGrp="1"/>
+          </p:cNvSpPr>
+          <p:nvPr>
+            <p:ph type="body" idx="1"/>
+          </p:nvPr>
+        </p:nvSpPr>
+        <p:spPr/>
+        <p:txBody>
+          <a:bodyPr/>
+          <a:lstStyle/>
+          <a:p>
+            <a:r>
+              <a:rPr lang="en-US" dirty="0"/>
+              <a:t/>
+            </a:r>
+            <a:endParaRPr lang="en-US" dirty="0"/>
+          </a:p>
+        </p:txBody>
+      </p:sp>
+      <p:sp>
+        <p:nvSpPr>
+          <p:cNvPr id="4" name="Slide Number Placeholder 3"/>
+          <p:cNvSpPr>
+            <a:spLocks noGrp="1"/>
+          </p:cNvSpPr>
+          <p:nvPr>
+            <p:ph type="sldNum" sz="quarter" idx="10"/>
+          </p:nvPr>
+        </p:nvSpPr>
+        <p:spPr/>
+        <p:txBody>
+          <a:bodyPr/>
+          <a:lstStyle/>
+          <a:p>
+            <a:fld id="{F7021451-1387-4CA6-816F-3879F97B5CBC}" type="slidenum">
+              <a:rPr lang="en-US"/>
+              <a:t>92</a:t>
+            </a:fld>
+            <a:endParaRPr lang="en-US"/>
+          </a:p>
+        </p:txBody>
+      </p:sp>
+    </p:spTree>
+    <p:extLst>
+      <p:ext uri="{BB962C8B-B14F-4D97-AF65-F5344CB8AC3E}">
+        <p14:creationId xmlns:p14="http://schemas.microsoft.com/office/powerpoint/2010/main" val="1024086991"/>
+      </p:ext>
+    </p:extLst>
+  </p:cSld>
+  <p:clrMapOvr>
+    <a:masterClrMapping/>
+  </p:clrMapOvr>
+</p:notes>
+</file>
+
+<file path=ppt/notesSlides/notesSlide93.xml><?xml version="1.0" encoding="utf-8"?>
+<p:notes xmlns:a="http://schemas.openxmlformats.org/drawingml/2006/main" xmlns:r="http://schemas.openxmlformats.org/officeDocument/2006/relationships" xmlns:p="http://schemas.openxmlformats.org/presentationml/2006/main">
+  <p:cSld>
+    <p:spTree>
+      <p:nvGrpSpPr>
+        <p:cNvPr id="1" name=""/>
+        <p:cNvGrpSpPr/>
+        <p:nvPr/>
+      </p:nvGrpSpPr>
+      <p:grpSpPr>
+        <a:xfrm>
+          <a:off x="0" y="0"/>
+          <a:ext cx="0" cy="0"/>
+          <a:chOff x="0" y="0"/>
+          <a:chExt cx="0" cy="0"/>
+        </a:xfrm>
+      </p:grpSpPr>
+      <p:sp>
+        <p:nvSpPr>
+          <p:cNvPr id="2" name="Slide Image Placeholder 1"/>
+          <p:cNvSpPr>
+            <a:spLocks noGrp="1" noRot="1" noChangeAspect="1"/>
+          </p:cNvSpPr>
+          <p:nvPr>
+            <p:ph type="sldImg"/>
+          </p:nvPr>
+        </p:nvSpPr>
+        <p:spPr/>
+      </p:sp>
+      <p:sp>
+        <p:nvSpPr>
+          <p:cNvPr id="3" name="Notes Placeholder 2"/>
+          <p:cNvSpPr>
+            <a:spLocks noGrp="1"/>
+          </p:cNvSpPr>
+          <p:nvPr>
+            <p:ph type="body" idx="1"/>
+          </p:nvPr>
+        </p:nvSpPr>
+        <p:spPr/>
+        <p:txBody>
+          <a:bodyPr/>
+          <a:lstStyle/>
+          <a:p>
+            <a:r>
+              <a:rPr lang="en-US" dirty="0"/>
+              <a:t/>
+            </a:r>
+            <a:endParaRPr lang="en-US" dirty="0"/>
+          </a:p>
+        </p:txBody>
+      </p:sp>
+      <p:sp>
+        <p:nvSpPr>
+          <p:cNvPr id="4" name="Slide Number Placeholder 3"/>
+          <p:cNvSpPr>
+            <a:spLocks noGrp="1"/>
+          </p:cNvSpPr>
+          <p:nvPr>
+            <p:ph type="sldNum" sz="quarter" idx="10"/>
+          </p:nvPr>
+        </p:nvSpPr>
+        <p:spPr/>
+        <p:txBody>
+          <a:bodyPr/>
+          <a:lstStyle/>
+          <a:p>
+            <a:fld id="{F7021451-1387-4CA6-816F-3879F97B5CBC}" type="slidenum">
+              <a:rPr lang="en-US"/>
+              <a:t>93</a:t>
+            </a:fld>
+            <a:endParaRPr lang="en-US"/>
+          </a:p>
+        </p:txBody>
+      </p:sp>
+    </p:spTree>
+    <p:extLst>
+      <p:ext uri="{BB962C8B-B14F-4D97-AF65-F5344CB8AC3E}">
+        <p14:creationId xmlns:p14="http://schemas.microsoft.com/office/powerpoint/2010/main" val="1024086991"/>
+      </p:ext>
+    </p:extLst>
+  </p:cSld>
+  <p:clrMapOvr>
+    <a:masterClrMapping/>
+  </p:clrMapOvr>
+</p:notes>
+</file>
+
+<file path=ppt/notesSlides/notesSlide94.xml><?xml version="1.0" encoding="utf-8"?>
+<p:notes xmlns:a="http://schemas.openxmlformats.org/drawingml/2006/main" xmlns:r="http://schemas.openxmlformats.org/officeDocument/2006/relationships" xmlns:p="http://schemas.openxmlformats.org/presentationml/2006/main">
+  <p:cSld>
+    <p:spTree>
+      <p:nvGrpSpPr>
+        <p:cNvPr id="1" name=""/>
+        <p:cNvGrpSpPr/>
+        <p:nvPr/>
+      </p:nvGrpSpPr>
+      <p:grpSpPr>
+        <a:xfrm>
+          <a:off x="0" y="0"/>
+          <a:ext cx="0" cy="0"/>
+          <a:chOff x="0" y="0"/>
+          <a:chExt cx="0" cy="0"/>
+        </a:xfrm>
+      </p:grpSpPr>
+      <p:sp>
+        <p:nvSpPr>
+          <p:cNvPr id="2" name="Slide Image Placeholder 1"/>
+          <p:cNvSpPr>
+            <a:spLocks noGrp="1" noRot="1" noChangeAspect="1"/>
+          </p:cNvSpPr>
+          <p:nvPr>
+            <p:ph type="sldImg"/>
+          </p:nvPr>
+        </p:nvSpPr>
+        <p:spPr/>
+      </p:sp>
+      <p:sp>
+        <p:nvSpPr>
+          <p:cNvPr id="3" name="Notes Placeholder 2"/>
+          <p:cNvSpPr>
+            <a:spLocks noGrp="1"/>
+          </p:cNvSpPr>
+          <p:nvPr>
+            <p:ph type="body" idx="1"/>
+          </p:nvPr>
+        </p:nvSpPr>
+        <p:spPr/>
+        <p:txBody>
+          <a:bodyPr/>
+          <a:lstStyle/>
+          <a:p>
+            <a:r>
+              <a:rPr lang="en-US" dirty="0"/>
+              <a:t/>
+            </a:r>
+            <a:endParaRPr lang="en-US" dirty="0"/>
+          </a:p>
+        </p:txBody>
+      </p:sp>
+      <p:sp>
+        <p:nvSpPr>
+          <p:cNvPr id="4" name="Slide Number Placeholder 3"/>
+          <p:cNvSpPr>
+            <a:spLocks noGrp="1"/>
+          </p:cNvSpPr>
+          <p:nvPr>
+            <p:ph type="sldNum" sz="quarter" idx="10"/>
+          </p:nvPr>
+        </p:nvSpPr>
+        <p:spPr/>
+        <p:txBody>
+          <a:bodyPr/>
+          <a:lstStyle/>
+          <a:p>
+            <a:fld id="{F7021451-1387-4CA6-816F-3879F97B5CBC}" type="slidenum">
+              <a:rPr lang="en-US"/>
+              <a:t>94</a:t>
             </a:fld>
             <a:endParaRPr lang="en-US"/>
           </a:p>
@@ -20010,7 +20277,7 @@
         </p:nvSpPr>
         <p:spPr>
           <a:xfrm>
-            <a:off x="6217920" y="1280160"/>
+            <a:off x="640080" y="6949440"/>
             <a:ext cx="457200" cy="457200"/>
           </a:xfrm>
           <a:prstGeom prst="rect">
@@ -20049,7 +20316,7 @@
         </p:nvSpPr>
         <p:spPr>
           <a:xfrm>
-            <a:off x="6720840" y="1280160"/>
+            <a:off x="1143000" y="6949440"/>
             <a:ext cx="4846320" cy="457200"/>
           </a:xfrm>
           <a:prstGeom prst="rect">
@@ -20088,7 +20355,7 @@
         </p:nvSpPr>
         <p:spPr>
           <a:xfrm>
-            <a:off x="6217920" y="1847088"/>
+            <a:off x="6217920" y="1280160"/>
             <a:ext cx="457200" cy="457200"/>
           </a:xfrm>
           <a:prstGeom prst="rect">
@@ -20127,7 +20394,7 @@
         </p:nvSpPr>
         <p:spPr>
           <a:xfrm>
-            <a:off x="6720840" y="1847088"/>
+            <a:off x="6720840" y="1280160"/>
             <a:ext cx="4846320" cy="457200"/>
           </a:xfrm>
           <a:prstGeom prst="rect">
@@ -20166,7 +20433,7 @@
         </p:nvSpPr>
         <p:spPr>
           <a:xfrm>
-            <a:off x="6217920" y="2414016"/>
+            <a:off x="6217920" y="1847088"/>
             <a:ext cx="457200" cy="457200"/>
           </a:xfrm>
           <a:prstGeom prst="rect">
@@ -20205,7 +20472,7 @@
         </p:nvSpPr>
         <p:spPr>
           <a:xfrm>
-            <a:off x="6720840" y="2414016"/>
+            <a:off x="6720840" y="1847088"/>
             <a:ext cx="4846320" cy="457200"/>
           </a:xfrm>
           <a:prstGeom prst="rect">
@@ -20244,7 +20511,7 @@
         </p:nvSpPr>
         <p:spPr>
           <a:xfrm>
-            <a:off x="6217920" y="2980944"/>
+            <a:off x="6217920" y="2414016"/>
             <a:ext cx="457200" cy="457200"/>
           </a:xfrm>
           <a:prstGeom prst="rect">
@@ -20283,7 +20550,7 @@
         </p:nvSpPr>
         <p:spPr>
           <a:xfrm>
-            <a:off x="6720840" y="2980944"/>
+            <a:off x="6720840" y="2414016"/>
             <a:ext cx="4846320" cy="457200"/>
           </a:xfrm>
           <a:prstGeom prst="rect">
@@ -20322,7 +20589,7 @@
         </p:nvSpPr>
         <p:spPr>
           <a:xfrm>
-            <a:off x="6217920" y="3547872"/>
+            <a:off x="6217920" y="2980944"/>
             <a:ext cx="457200" cy="457200"/>
           </a:xfrm>
           <a:prstGeom prst="rect">
@@ -20361,7 +20628,7 @@
         </p:nvSpPr>
         <p:spPr>
           <a:xfrm>
-            <a:off x="6720840" y="3547872"/>
+            <a:off x="6720840" y="2980944"/>
             <a:ext cx="4846320" cy="457200"/>
           </a:xfrm>
           <a:prstGeom prst="rect">
@@ -20400,7 +20667,7 @@
         </p:nvSpPr>
         <p:spPr>
           <a:xfrm>
-            <a:off x="6217920" y="4114800"/>
+            <a:off x="6217920" y="3547872"/>
             <a:ext cx="457200" cy="457200"/>
           </a:xfrm>
           <a:prstGeom prst="rect">
@@ -20439,7 +20706,7 @@
         </p:nvSpPr>
         <p:spPr>
           <a:xfrm>
-            <a:off x="6720840" y="4114800"/>
+            <a:off x="6720840" y="3547872"/>
             <a:ext cx="4846320" cy="457200"/>
           </a:xfrm>
           <a:prstGeom prst="rect">
@@ -20478,7 +20745,7 @@
         </p:nvSpPr>
         <p:spPr>
           <a:xfrm>
-            <a:off x="6217920" y="4681728"/>
+            <a:off x="6217920" y="4114800"/>
             <a:ext cx="457200" cy="457200"/>
           </a:xfrm>
           <a:prstGeom prst="rect">
@@ -20517,7 +20784,7 @@
         </p:nvSpPr>
         <p:spPr>
           <a:xfrm>
-            <a:off x="6720840" y="4681728"/>
+            <a:off x="6720840" y="4114800"/>
             <a:ext cx="4846320" cy="457200"/>
           </a:xfrm>
           <a:prstGeom prst="rect">
@@ -20556,7 +20823,7 @@
         </p:nvSpPr>
         <p:spPr>
           <a:xfrm>
-            <a:off x="6217920" y="5248656"/>
+            <a:off x="6217920" y="4681728"/>
             <a:ext cx="457200" cy="457200"/>
           </a:xfrm>
           <a:prstGeom prst="rect">
@@ -20595,7 +20862,7 @@
         </p:nvSpPr>
         <p:spPr>
           <a:xfrm>
-            <a:off x="6720840" y="5248656"/>
+            <a:off x="6720840" y="4681728"/>
             <a:ext cx="4846320" cy="457200"/>
           </a:xfrm>
           <a:prstGeom prst="rect">
@@ -20634,7 +20901,7 @@
         </p:nvSpPr>
         <p:spPr>
           <a:xfrm>
-            <a:off x="6217920" y="5815584"/>
+            <a:off x="6217920" y="5248656"/>
             <a:ext cx="457200" cy="457200"/>
           </a:xfrm>
           <a:prstGeom prst="rect">
@@ -20673,7 +20940,7 @@
         </p:nvSpPr>
         <p:spPr>
           <a:xfrm>
-            <a:off x="6720840" y="5815584"/>
+            <a:off x="6720840" y="5248656"/>
             <a:ext cx="4846320" cy="457200"/>
           </a:xfrm>
           <a:prstGeom prst="rect">
@@ -20712,7 +20979,7 @@
         </p:nvSpPr>
         <p:spPr>
           <a:xfrm>
-            <a:off x="6217920" y="6382512"/>
+            <a:off x="6217920" y="5815584"/>
             <a:ext cx="457200" cy="457200"/>
           </a:xfrm>
           <a:prstGeom prst="rect">
@@ -20751,6 +21018,84 @@
         </p:nvSpPr>
         <p:spPr>
           <a:xfrm>
+            <a:off x="6720840" y="5815584"/>
+            <a:ext cx="4846320" cy="457200"/>
+          </a:xfrm>
+          <a:prstGeom prst="rect">
+            <a:avLst/>
+          </a:prstGeom>
+          <a:noFill/>
+          <a:ln/>
+        </p:spPr>
+        <p:txBody>
+          <a:bodyPr wrap="square" rtlCol="0" anchor="t"/>
+          <a:lstStyle/>
+          <a:p>
+            <a:pPr indent="0" marL="0">
+              <a:buNone/>
+            </a:pPr>
+            <a:r>
+              <a:rPr lang="en-US" sz="1300" dirty="0">
+                <a:solidFill>
+                  <a:srgbClr val="1B1F3B"/>
+                </a:solidFill>
+                <a:latin typeface="Segoe UI" pitchFamily="34" charset="0"/>
+                <a:ea typeface="Segoe UI" pitchFamily="34" charset="-122"/>
+                <a:cs typeface="Segoe UI" pitchFamily="34" charset="-120"/>
+              </a:rPr>
+              <a:t>Sécurité, données et multilinguisme</a:t>
+            </a:r>
+            <a:endParaRPr lang="en-US" sz="1300" dirty="0"/>
+          </a:p>
+        </p:txBody>
+      </p:sp>
+      <p:sp>
+        <p:nvSpPr>
+          <p:cNvPr id="43" name="Text 41"/>
+          <p:cNvSpPr/>
+          <p:nvPr/>
+        </p:nvSpPr>
+        <p:spPr>
+          <a:xfrm>
+            <a:off x="6217920" y="6382512"/>
+            <a:ext cx="457200" cy="457200"/>
+          </a:xfrm>
+          <a:prstGeom prst="rect">
+            <a:avLst/>
+          </a:prstGeom>
+          <a:noFill/>
+          <a:ln/>
+        </p:spPr>
+        <p:txBody>
+          <a:bodyPr wrap="square" rtlCol="0" anchor="ctr"/>
+          <a:lstStyle/>
+          <a:p>
+            <a:pPr indent="0" marL="0">
+              <a:buNone/>
+            </a:pPr>
+            <a:r>
+              <a:rPr lang="en-US" sz="1300" b="1" dirty="0">
+                <a:solidFill>
+                  <a:srgbClr val="C9A96A"/>
+                </a:solidFill>
+                <a:latin typeface="Georgia" pitchFamily="34" charset="0"/>
+                <a:ea typeface="Georgia" pitchFamily="34" charset="-122"/>
+                <a:cs typeface="Georgia" pitchFamily="34" charset="-120"/>
+              </a:rPr>
+              <a:t>21</a:t>
+            </a:r>
+            <a:endParaRPr lang="en-US" sz="1300" dirty="0"/>
+          </a:p>
+        </p:txBody>
+      </p:sp>
+      <p:sp>
+        <p:nvSpPr>
+          <p:cNvPr id="44" name="Text 42"/>
+          <p:cNvSpPr/>
+          <p:nvPr/>
+        </p:nvSpPr>
+        <p:spPr>
+          <a:xfrm>
             <a:off x="6720840" y="6382512"/>
             <a:ext cx="4846320" cy="457200"/>
           </a:xfrm>
@@ -20776,7 +21121,7 @@
                 <a:ea typeface="Segoe UI" pitchFamily="34" charset="-122"/>
                 <a:cs typeface="Segoe UI" pitchFamily="34" charset="-120"/>
               </a:rPr>
-              <a:t>Sécurité, données et multilinguisme</a:t>
+              <a:t>Évolutions récentes — Koji Pro (Octobre 2026)</a:t>
             </a:r>
             <a:endParaRPr lang="en-US" sz="1300" dirty="0"/>
           </a:p>
@@ -20784,7 +21129,7 @@
       </p:sp>
       <p:sp>
         <p:nvSpPr>
-          <p:cNvPr id="43" name="Text 41"/>
+          <p:cNvPr id="45" name="Text 43"/>
           <p:cNvSpPr/>
           <p:nvPr/>
         </p:nvSpPr>
@@ -20823,7 +21168,7 @@
       </p:sp>
       <p:sp>
         <p:nvSpPr>
-          <p:cNvPr id="44" name="Text 42"/>
+          <p:cNvPr id="46" name="Text 44"/>
           <p:cNvSpPr/>
           <p:nvPr/>
         </p:nvSpPr>
@@ -47608,6 +47953,982 @@
 <file path=ppt/slides/slide91.xml><?xml version="1.0" encoding="utf-8"?>
 <p:sld xmlns:a="http://schemas.openxmlformats.org/drawingml/2006/main" xmlns:r="http://schemas.openxmlformats.org/officeDocument/2006/relationships" xmlns:p="http://schemas.openxmlformats.org/presentationml/2006/main">
   <p:cSld name="Slide 91">
+    <p:bg>
+      <p:bgPr>
+        <a:solidFill>
+          <a:srgbClr val="0B1030"/>
+        </a:solidFill>
+      </p:bgPr>
+    </p:bg>
+    <p:spTree>
+      <p:nvGrpSpPr>
+        <p:cNvPr id="1" name=""/>
+        <p:cNvGrpSpPr/>
+        <p:nvPr/>
+      </p:nvGrpSpPr>
+      <p:grpSpPr>
+        <a:xfrm>
+          <a:off x="0" y="0"/>
+          <a:ext cx="0" cy="0"/>
+          <a:chOff x="0" y="0"/>
+          <a:chExt cx="0" cy="0"/>
+        </a:xfrm>
+      </p:grpSpPr>
+      <p:sp>
+        <p:nvSpPr>
+          <p:cNvPr id="2" name="Shape 0"/>
+          <p:cNvSpPr/>
+          <p:nvPr/>
+        </p:nvSpPr>
+        <p:spPr>
+          <a:xfrm>
+            <a:off x="0" y="3246120"/>
+            <a:ext cx="12191695" cy="54864"/>
+          </a:xfrm>
+          <a:prstGeom prst="rect">
+            <a:avLst/>
+          </a:prstGeom>
+          <a:solidFill>
+            <a:srgbClr val="C9A96A"/>
+          </a:solidFill>
+          <a:ln/>
+        </p:spPr>
+      </p:sp>
+      <p:sp>
+        <p:nvSpPr>
+          <p:cNvPr id="3" name="Text 1"/>
+          <p:cNvSpPr/>
+          <p:nvPr/>
+        </p:nvSpPr>
+        <p:spPr>
+          <a:xfrm>
+            <a:off x="640080" y="1920240"/>
+            <a:ext cx="2743200" cy="548640"/>
+          </a:xfrm>
+          <a:prstGeom prst="rect">
+            <a:avLst/>
+          </a:prstGeom>
+          <a:noFill/>
+          <a:ln/>
+        </p:spPr>
+        <p:txBody>
+          <a:bodyPr wrap="square" rtlCol="0" anchor="ctr"/>
+          <a:lstStyle/>
+          <a:p>
+            <a:pPr indent="0" marL="0">
+              <a:buNone/>
+            </a:pPr>
+            <a:r>
+              <a:rPr lang="en-US" sz="1500" b="1" dirty="0">
+                <a:solidFill>
+                  <a:srgbClr val="C9A96A"/>
+                </a:solidFill>
+                <a:latin typeface="Segoe UI" pitchFamily="34" charset="0"/>
+                <a:ea typeface="Segoe UI" pitchFamily="34" charset="-122"/>
+                <a:cs typeface="Segoe UI" pitchFamily="34" charset="-120"/>
+              </a:rPr>
+              <a:t>21</a:t>
+            </a:r>
+            <a:endParaRPr lang="en-US" sz="1500" dirty="0"/>
+          </a:p>
+        </p:txBody>
+      </p:sp>
+      <p:sp>
+        <p:nvSpPr>
+          <p:cNvPr id="4" name="Text 2"/>
+          <p:cNvSpPr/>
+          <p:nvPr/>
+        </p:nvSpPr>
+        <p:spPr>
+          <a:xfrm>
+            <a:off x="640080" y="2377440"/>
+            <a:ext cx="10515600" cy="914400"/>
+          </a:xfrm>
+          <a:prstGeom prst="rect">
+            <a:avLst/>
+          </a:prstGeom>
+          <a:noFill/>
+          <a:ln/>
+        </p:spPr>
+        <p:txBody>
+          <a:bodyPr wrap="square" rtlCol="0" anchor="ctr"/>
+          <a:lstStyle/>
+          <a:p>
+            <a:pPr indent="0" marL="0">
+              <a:buNone/>
+            </a:pPr>
+            <a:r>
+              <a:rPr lang="en-US" sz="3400" b="1" dirty="0">
+                <a:solidFill>
+                  <a:srgbClr val="FFFFFF"/>
+                </a:solidFill>
+                <a:latin typeface="Georgia" pitchFamily="34" charset="0"/>
+                <a:ea typeface="Georgia" pitchFamily="34" charset="-122"/>
+                <a:cs typeface="Georgia" pitchFamily="34" charset="-120"/>
+              </a:rPr>
+              <a:t>Évolutions récentes — Koji Pro (Octobre 2026)</a:t>
+            </a:r>
+            <a:endParaRPr lang="en-US" sz="3400" dirty="0"/>
+          </a:p>
+        </p:txBody>
+      </p:sp>
+      <p:sp>
+        <p:nvSpPr>
+          <p:cNvPr id="5" name="Text 3"/>
+          <p:cNvSpPr/>
+          <p:nvPr/>
+        </p:nvSpPr>
+        <p:spPr>
+          <a:xfrm>
+            <a:off x="640080" y="3429000"/>
+            <a:ext cx="10058400" cy="1188720"/>
+          </a:xfrm>
+          <a:prstGeom prst="rect">
+            <a:avLst/>
+          </a:prstGeom>
+          <a:noFill/>
+          <a:ln/>
+        </p:spPr>
+        <p:txBody>
+          <a:bodyPr wrap="square" rtlCol="0" anchor="ctr"/>
+          <a:lstStyle/>
+          <a:p>
+            <a:pPr indent="0" marL="0">
+              <a:lnSpc>
+                <a:spcPts val="1800"/>
+              </a:lnSpc>
+              <a:buNone/>
+            </a:pPr>
+            <a:r>
+              <a:rPr lang="en-US" sz="1300" dirty="0">
+                <a:solidFill>
+                  <a:srgbClr val="C7C9E0"/>
+                </a:solidFill>
+                <a:latin typeface="Segoe UI" pitchFamily="34" charset="0"/>
+                <a:ea typeface="Segoe UI" pitchFamily="34" charset="-122"/>
+                <a:cs typeface="Segoe UI" pitchFamily="34" charset="-120"/>
+              </a:rPr>
+              <a:t>Refonte complète de l'interface Koji Pro réalisée en octobre 2026, incluant la redesign du dashboard web et de l'application mobile.</a:t>
+            </a:r>
+            <a:endParaRPr lang="en-US" sz="1300" dirty="0"/>
+          </a:p>
+        </p:txBody>
+      </p:sp>
+      <p:sp>
+        <p:nvSpPr>
+          <p:cNvPr id="6" name="Text 4"/>
+          <p:cNvSpPr/>
+          <p:nvPr/>
+        </p:nvSpPr>
+        <p:spPr>
+          <a:xfrm>
+            <a:off x="365760" y="6510528"/>
+            <a:ext cx="5486400" cy="274320"/>
+          </a:xfrm>
+          <a:prstGeom prst="rect">
+            <a:avLst/>
+          </a:prstGeom>
+          <a:noFill/>
+          <a:ln/>
+        </p:spPr>
+        <p:txBody>
+          <a:bodyPr wrap="square" rtlCol="0" anchor="ctr"/>
+          <a:lstStyle/>
+          <a:p>
+            <a:pPr indent="0" marL="0">
+              <a:buNone/>
+            </a:pPr>
+            <a:r>
+              <a:rPr lang="en-US" sz="850" dirty="0">
+                <a:solidFill>
+                  <a:srgbClr val="8A7C68"/>
+                </a:solidFill>
+                <a:latin typeface="Segoe UI" pitchFamily="34" charset="0"/>
+                <a:ea typeface="Segoe UI" pitchFamily="34" charset="-122"/>
+                <a:cs typeface="Segoe UI" pitchFamily="34" charset="-120"/>
+              </a:rPr>
+              <a:t>Koji Web — Cahier des charges</a:t>
+            </a:r>
+            <a:endParaRPr lang="en-US" sz="850" dirty="0"/>
+          </a:p>
+        </p:txBody>
+      </p:sp>
+      <p:sp>
+        <p:nvSpPr>
+          <p:cNvPr id="7" name="Text 5"/>
+          <p:cNvSpPr/>
+          <p:nvPr/>
+        </p:nvSpPr>
+        <p:spPr>
+          <a:xfrm>
+            <a:off x="9601200" y="6510528"/>
+            <a:ext cx="2194560" cy="274320"/>
+          </a:xfrm>
+          <a:prstGeom prst="rect">
+            <a:avLst/>
+          </a:prstGeom>
+          <a:noFill/>
+          <a:ln/>
+        </p:spPr>
+        <p:txBody>
+          <a:bodyPr wrap="square" rtlCol="0" anchor="ctr"/>
+          <a:lstStyle/>
+          <a:p>
+            <a:pPr algn="r" indent="0" marL="0">
+              <a:buNone/>
+            </a:pPr>
+            <a:r>
+              <a:rPr lang="en-US" sz="850" dirty="0">
+                <a:solidFill>
+                  <a:srgbClr val="8A7C68"/>
+                </a:solidFill>
+                <a:latin typeface="Segoe UI" pitchFamily="34" charset="0"/>
+                <a:ea typeface="Segoe UI" pitchFamily="34" charset="-122"/>
+                <a:cs typeface="Segoe UI" pitchFamily="34" charset="-120"/>
+              </a:rPr>
+              <a:t>90</a:t>
+            </a:r>
+            <a:endParaRPr lang="en-US" sz="850" dirty="0"/>
+          </a:p>
+        </p:txBody>
+      </p:sp>
+    </p:spTree>
+  </p:cSld>
+  <p:clrMapOvr>
+    <a:masterClrMapping/>
+  </p:clrMapOvr>
+</p:sld>
+</file>
+
+<file path=ppt/slides/slide92.xml><?xml version="1.0" encoding="utf-8"?>
+<p:sld xmlns:a="http://schemas.openxmlformats.org/drawingml/2006/main" xmlns:r="http://schemas.openxmlformats.org/officeDocument/2006/relationships" xmlns:p="http://schemas.openxmlformats.org/presentationml/2006/main">
+  <p:cSld name="Slide 92">
+    <p:bg>
+      <p:bgPr>
+        <a:solidFill>
+          <a:srgbClr val="F3EEE3"/>
+        </a:solidFill>
+      </p:bgPr>
+    </p:bg>
+    <p:spTree>
+      <p:nvGrpSpPr>
+        <p:cNvPr id="1" name=""/>
+        <p:cNvGrpSpPr/>
+        <p:nvPr/>
+      </p:nvGrpSpPr>
+      <p:grpSpPr>
+        <a:xfrm>
+          <a:off x="0" y="0"/>
+          <a:ext cx="0" cy="0"/>
+          <a:chOff x="0" y="0"/>
+          <a:chExt cx="0" cy="0"/>
+        </a:xfrm>
+      </p:grpSpPr>
+      <p:sp>
+        <p:nvSpPr>
+          <p:cNvPr id="2" name="Shape 0"/>
+          <p:cNvSpPr/>
+          <p:nvPr/>
+        </p:nvSpPr>
+        <p:spPr>
+          <a:xfrm>
+            <a:off x="640080" y="411480"/>
+            <a:ext cx="3108960" cy="365760"/>
+          </a:xfrm>
+          <a:prstGeom prst="roundRect">
+            <a:avLst>
+              <a:gd name="adj" fmla="val 50000"/>
+            </a:avLst>
+          </a:prstGeom>
+          <a:solidFill>
+            <a:srgbClr val="F7EADF"/>
+          </a:solidFill>
+          <a:ln/>
+        </p:spPr>
+      </p:sp>
+      <p:sp>
+        <p:nvSpPr>
+          <p:cNvPr id="3" name="Text 1"/>
+          <p:cNvSpPr/>
+          <p:nvPr/>
+        </p:nvSpPr>
+        <p:spPr>
+          <a:xfrm>
+            <a:off x="640080" y="411480"/>
+            <a:ext cx="3108960" cy="365760"/>
+          </a:xfrm>
+          <a:prstGeom prst="rect">
+            <a:avLst/>
+          </a:prstGeom>
+          <a:noFill/>
+          <a:ln/>
+        </p:spPr>
+        <p:txBody>
+          <a:bodyPr wrap="square" rtlCol="0" anchor="ctr"/>
+          <a:lstStyle/>
+          <a:p>
+            <a:pPr algn="ctr" indent="0" marL="0">
+              <a:buNone/>
+            </a:pPr>
+            <a:r>
+              <a:rPr lang="en-US" sz="950" b="1" spc="100" kern="0" dirty="0">
+                <a:solidFill>
+                  <a:srgbClr val="9A7C5C"/>
+                </a:solidFill>
+                <a:latin typeface="Segoe UI" pitchFamily="34" charset="0"/>
+                <a:ea typeface="Segoe UI" pitchFamily="34" charset="-122"/>
+                <a:cs typeface="Segoe UI" pitchFamily="34" charset="-120"/>
+              </a:rPr>
+              <a:t>ÉVOLUTIONS RÉCENTES — KOJI PRO (OCTOBRE 2026)</a:t>
+            </a:r>
+            <a:endParaRPr lang="en-US" sz="950" dirty="0"/>
+          </a:p>
+        </p:txBody>
+      </p:sp>
+      <p:sp>
+        <p:nvSpPr>
+          <p:cNvPr id="4" name="Shape 2"/>
+          <p:cNvSpPr/>
+          <p:nvPr/>
+        </p:nvSpPr>
+        <p:spPr>
+          <a:xfrm>
+            <a:off x="640080" y="1005840"/>
+            <a:ext cx="10881360" cy="1737360"/>
+          </a:xfrm>
+          <a:prstGeom prst="roundRect">
+            <a:avLst>
+              <a:gd name="adj" fmla="val 3158"/>
+            </a:avLst>
+          </a:prstGeom>
+          <a:solidFill>
+            <a:srgbClr val="FFFFFF"/>
+          </a:solidFill>
+          <a:ln w="12700">
+            <a:solidFill>
+              <a:srgbClr val="E4DCCB"/>
+            </a:solidFill>
+            <a:prstDash val="solid"/>
+          </a:ln>
+        </p:spPr>
+      </p:sp>
+      <p:sp>
+        <p:nvSpPr>
+          <p:cNvPr id="5" name="Shape 3"/>
+          <p:cNvSpPr/>
+          <p:nvPr/>
+        </p:nvSpPr>
+        <p:spPr>
+          <a:xfrm>
+            <a:off x="640080" y="1005840"/>
+            <a:ext cx="54864" cy="1737360"/>
+          </a:xfrm>
+          <a:prstGeom prst="rect">
+            <a:avLst/>
+          </a:prstGeom>
+          <a:solidFill>
+            <a:srgbClr val="1D6FE0"/>
+          </a:solidFill>
+          <a:ln/>
+        </p:spPr>
+      </p:sp>
+      <p:sp>
+        <p:nvSpPr>
+          <p:cNvPr id="6" name="Text 4"/>
+          <p:cNvSpPr/>
+          <p:nvPr/>
+        </p:nvSpPr>
+        <p:spPr>
+          <a:xfrm>
+            <a:off x="914400" y="1133856"/>
+            <a:ext cx="10332720" cy="365760"/>
+          </a:xfrm>
+          <a:prstGeom prst="rect">
+            <a:avLst/>
+          </a:prstGeom>
+          <a:noFill/>
+          <a:ln/>
+        </p:spPr>
+        <p:txBody>
+          <a:bodyPr wrap="square" rtlCol="0" anchor="ctr"/>
+          <a:lstStyle/>
+          <a:p>
+            <a:pPr indent="0" marL="0">
+              <a:buNone/>
+            </a:pPr>
+            <a:r>
+              <a:rPr lang="en-US" sz="1500" b="1" dirty="0">
+                <a:solidFill>
+                  <a:srgbClr val="1B1F3B"/>
+                </a:solidFill>
+                <a:latin typeface="Georgia" pitchFamily="34" charset="0"/>
+                <a:ea typeface="Georgia" pitchFamily="34" charset="-122"/>
+                <a:cs typeface="Georgia" pitchFamily="34" charset="-120"/>
+              </a:rPr>
+              <a:t>Refonte intégrale du dashboard entreprise (50 pages web)</a:t>
+            </a:r>
+            <a:endParaRPr lang="en-US" sz="1500" dirty="0"/>
+          </a:p>
+        </p:txBody>
+      </p:sp>
+      <p:sp>
+        <p:nvSpPr>
+          <p:cNvPr id="7" name="Text 5"/>
+          <p:cNvSpPr/>
+          <p:nvPr/>
+        </p:nvSpPr>
+        <p:spPr>
+          <a:xfrm>
+            <a:off x="914400" y="1536192"/>
+            <a:ext cx="10332720" cy="1005840"/>
+          </a:xfrm>
+          <a:prstGeom prst="rect">
+            <a:avLst/>
+          </a:prstGeom>
+          <a:noFill/>
+          <a:ln/>
+        </p:spPr>
+        <p:txBody>
+          <a:bodyPr wrap="square" rtlCol="0" anchor="ctr"/>
+          <a:lstStyle/>
+          <a:p>
+            <a:pPr indent="0" marL="0">
+              <a:lnSpc>
+                <a:spcPts val="1600"/>
+              </a:lnSpc>
+              <a:buNone/>
+            </a:pPr>
+            <a:r>
+              <a:rPr lang="en-US" sz="1150" dirty="0">
+                <a:solidFill>
+                  <a:srgbClr val="1B1F3B"/>
+                </a:solidFill>
+                <a:latin typeface="Segoe UI" pitchFamily="34" charset="0"/>
+                <a:ea typeface="Segoe UI" pitchFamily="34" charset="-122"/>
+                <a:cs typeface="Segoe UI" pitchFamily="34" charset="-120"/>
+              </a:rPr>
+              <a:t>Le dashboard Koji Pro a été entièrement refondu selon la nouvelle Design Appliqué (DA) : 50 pages répartis sur 12 modules (Chantiers, Devis, Facturation, Fournitures, Bibliothèque, Comptabilité, Contacts, Calendrier, KojiPage, Profil, Équipe, Urgences). Chaque module et sous-page respecte le design system PRO-01 à PRO-17, avec KPIs, listes, fiches détail et formulaires cohérents.</a:t>
+            </a:r>
+            <a:endParaRPr lang="en-US" sz="1150" dirty="0"/>
+          </a:p>
+        </p:txBody>
+      </p:sp>
+      <p:sp>
+        <p:nvSpPr>
+          <p:cNvPr id="8" name="Shape 6"/>
+          <p:cNvSpPr/>
+          <p:nvPr/>
+        </p:nvSpPr>
+        <p:spPr>
+          <a:xfrm>
+            <a:off x="640080" y="2944368"/>
+            <a:ext cx="10881360" cy="1737360"/>
+          </a:xfrm>
+          <a:prstGeom prst="roundRect">
+            <a:avLst>
+              <a:gd name="adj" fmla="val 3158"/>
+            </a:avLst>
+          </a:prstGeom>
+          <a:solidFill>
+            <a:srgbClr val="FFFFFF"/>
+          </a:solidFill>
+          <a:ln w="12700">
+            <a:solidFill>
+              <a:srgbClr val="E4DCCB"/>
+            </a:solidFill>
+            <a:prstDash val="solid"/>
+          </a:ln>
+        </p:spPr>
+      </p:sp>
+      <p:sp>
+        <p:nvSpPr>
+          <p:cNvPr id="9" name="Shape 7"/>
+          <p:cNvSpPr/>
+          <p:nvPr/>
+        </p:nvSpPr>
+        <p:spPr>
+          <a:xfrm>
+            <a:off x="640080" y="2944368"/>
+            <a:ext cx="54864" cy="1737360"/>
+          </a:xfrm>
+          <a:prstGeom prst="rect">
+            <a:avLst/>
+          </a:prstGeom>
+          <a:solidFill>
+            <a:srgbClr val="1D6FE0"/>
+          </a:solidFill>
+          <a:ln/>
+        </p:spPr>
+      </p:sp>
+      <p:sp>
+        <p:nvSpPr>
+          <p:cNvPr id="10" name="Text 8"/>
+          <p:cNvSpPr/>
+          <p:nvPr/>
+        </p:nvSpPr>
+        <p:spPr>
+          <a:xfrm>
+            <a:off x="914400" y="3072384"/>
+            <a:ext cx="10332720" cy="365760"/>
+          </a:xfrm>
+          <a:prstGeom prst="rect">
+            <a:avLst/>
+          </a:prstGeom>
+          <a:noFill/>
+          <a:ln/>
+        </p:spPr>
+        <p:txBody>
+          <a:bodyPr wrap="square" rtlCol="0" anchor="ctr"/>
+          <a:lstStyle/>
+          <a:p>
+            <a:pPr indent="0" marL="0">
+              <a:buNone/>
+            </a:pPr>
+            <a:r>
+              <a:rPr lang="en-US" sz="1500" b="1" dirty="0">
+                <a:solidFill>
+                  <a:srgbClr val="1B1F3B"/>
+                </a:solidFill>
+                <a:latin typeface="Georgia" pitchFamily="34" charset="0"/>
+                <a:ea typeface="Georgia" pitchFamily="34" charset="-122"/>
+                <a:cs typeface="Georgia" pitchFamily="34" charset="-120"/>
+              </a:rPr>
+              <a:t>Refonte intégrale de l'app mobile entreprise (5 fichiers Flutter)</a:t>
+            </a:r>
+            <a:endParaRPr lang="en-US" sz="1500" dirty="0"/>
+          </a:p>
+        </p:txBody>
+      </p:sp>
+      <p:sp>
+        <p:nvSpPr>
+          <p:cNvPr id="11" name="Text 9"/>
+          <p:cNvSpPr/>
+          <p:nvPr/>
+        </p:nvSpPr>
+        <p:spPr>
+          <a:xfrm>
+            <a:off x="914400" y="3474720"/>
+            <a:ext cx="10332720" cy="1005840"/>
+          </a:xfrm>
+          <a:prstGeom prst="rect">
+            <a:avLst/>
+          </a:prstGeom>
+          <a:noFill/>
+          <a:ln/>
+        </p:spPr>
+        <p:txBody>
+          <a:bodyPr wrap="square" rtlCol="0" anchor="ctr"/>
+          <a:lstStyle/>
+          <a:p>
+            <a:pPr indent="0" marL="0">
+              <a:lnSpc>
+                <a:spcPts val="1600"/>
+              </a:lnSpc>
+              <a:buNone/>
+            </a:pPr>
+            <a:r>
+              <a:rPr lang="en-US" sz="1150" dirty="0">
+                <a:solidFill>
+                  <a:srgbClr val="1B1F3B"/>
+                </a:solidFill>
+                <a:latin typeface="Segoe UI" pitchFamily="34" charset="0"/>
+                <a:ea typeface="Segoe UI" pitchFamily="34" charset="-122"/>
+                <a:cs typeface="Segoe UI" pitchFamily="34" charset="-120"/>
+              </a:rPr>
+              <a:t>L'application mobile Koji Pro a été refondée sur 5 fichiers (Accueil, Listes Devis/Clients/Équipe/Facturation, Assistant IA Devis, Profil et Paramètres, Options avancées). Tous les écrans utilisent le nouveau design system KOJI Pro (couleurs, composants, KPI cards mobiles, mise en page responsive).</a:t>
+            </a:r>
+            <a:endParaRPr lang="en-US" sz="1150" dirty="0"/>
+          </a:p>
+        </p:txBody>
+      </p:sp>
+      <p:sp>
+        <p:nvSpPr>
+          <p:cNvPr id="12" name="Text 10"/>
+          <p:cNvSpPr/>
+          <p:nvPr/>
+        </p:nvSpPr>
+        <p:spPr>
+          <a:xfrm>
+            <a:off x="365760" y="6510528"/>
+            <a:ext cx="5486400" cy="274320"/>
+          </a:xfrm>
+          <a:prstGeom prst="rect">
+            <a:avLst/>
+          </a:prstGeom>
+          <a:noFill/>
+          <a:ln/>
+        </p:spPr>
+        <p:txBody>
+          <a:bodyPr wrap="square" rtlCol="0" anchor="ctr"/>
+          <a:lstStyle/>
+          <a:p>
+            <a:pPr indent="0" marL="0">
+              <a:buNone/>
+            </a:pPr>
+            <a:r>
+              <a:rPr lang="en-US" sz="850" dirty="0">
+                <a:solidFill>
+                  <a:srgbClr val="8A7C68"/>
+                </a:solidFill>
+                <a:latin typeface="Segoe UI" pitchFamily="34" charset="0"/>
+                <a:ea typeface="Segoe UI" pitchFamily="34" charset="-122"/>
+                <a:cs typeface="Segoe UI" pitchFamily="34" charset="-120"/>
+              </a:rPr>
+              <a:t>Koji Web — Cahier des charges</a:t>
+            </a:r>
+            <a:endParaRPr lang="en-US" sz="850" dirty="0"/>
+          </a:p>
+        </p:txBody>
+      </p:sp>
+      <p:sp>
+        <p:nvSpPr>
+          <p:cNvPr id="13" name="Text 11"/>
+          <p:cNvSpPr/>
+          <p:nvPr/>
+        </p:nvSpPr>
+        <p:spPr>
+          <a:xfrm>
+            <a:off x="9601200" y="6510528"/>
+            <a:ext cx="2194560" cy="274320"/>
+          </a:xfrm>
+          <a:prstGeom prst="rect">
+            <a:avLst/>
+          </a:prstGeom>
+          <a:noFill/>
+          <a:ln/>
+        </p:spPr>
+        <p:txBody>
+          <a:bodyPr wrap="square" rtlCol="0" anchor="ctr"/>
+          <a:lstStyle/>
+          <a:p>
+            <a:pPr algn="r" indent="0" marL="0">
+              <a:buNone/>
+            </a:pPr>
+            <a:r>
+              <a:rPr lang="en-US" sz="850" dirty="0">
+                <a:solidFill>
+                  <a:srgbClr val="8A7C68"/>
+                </a:solidFill>
+                <a:latin typeface="Segoe UI" pitchFamily="34" charset="0"/>
+                <a:ea typeface="Segoe UI" pitchFamily="34" charset="-122"/>
+                <a:cs typeface="Segoe UI" pitchFamily="34" charset="-120"/>
+              </a:rPr>
+              <a:t>91</a:t>
+            </a:r>
+            <a:endParaRPr lang="en-US" sz="850" dirty="0"/>
+          </a:p>
+        </p:txBody>
+      </p:sp>
+    </p:spTree>
+  </p:cSld>
+  <p:clrMapOvr>
+    <a:masterClrMapping/>
+  </p:clrMapOvr>
+</p:sld>
+</file>
+
+<file path=ppt/slides/slide93.xml><?xml version="1.0" encoding="utf-8"?>
+<p:sld xmlns:a="http://schemas.openxmlformats.org/drawingml/2006/main" xmlns:r="http://schemas.openxmlformats.org/officeDocument/2006/relationships" xmlns:p="http://schemas.openxmlformats.org/presentationml/2006/main">
+  <p:cSld name="Slide 93">
+    <p:bg>
+      <p:bgPr>
+        <a:solidFill>
+          <a:srgbClr val="F3EEE3"/>
+        </a:solidFill>
+      </p:bgPr>
+    </p:bg>
+    <p:spTree>
+      <p:nvGrpSpPr>
+        <p:cNvPr id="1" name=""/>
+        <p:cNvGrpSpPr/>
+        <p:nvPr/>
+      </p:nvGrpSpPr>
+      <p:grpSpPr>
+        <a:xfrm>
+          <a:off x="0" y="0"/>
+          <a:ext cx="0" cy="0"/>
+          <a:chOff x="0" y="0"/>
+          <a:chExt cx="0" cy="0"/>
+        </a:xfrm>
+      </p:grpSpPr>
+      <p:sp>
+        <p:nvSpPr>
+          <p:cNvPr id="2" name="Shape 0"/>
+          <p:cNvSpPr/>
+          <p:nvPr/>
+        </p:nvSpPr>
+        <p:spPr>
+          <a:xfrm>
+            <a:off x="640080" y="411480"/>
+            <a:ext cx="3108960" cy="365760"/>
+          </a:xfrm>
+          <a:prstGeom prst="roundRect">
+            <a:avLst>
+              <a:gd name="adj" fmla="val 50000"/>
+            </a:avLst>
+          </a:prstGeom>
+          <a:solidFill>
+            <a:srgbClr val="F7EADF"/>
+          </a:solidFill>
+          <a:ln/>
+        </p:spPr>
+      </p:sp>
+      <p:sp>
+        <p:nvSpPr>
+          <p:cNvPr id="3" name="Text 1"/>
+          <p:cNvSpPr/>
+          <p:nvPr/>
+        </p:nvSpPr>
+        <p:spPr>
+          <a:xfrm>
+            <a:off x="640080" y="411480"/>
+            <a:ext cx="3108960" cy="365760"/>
+          </a:xfrm>
+          <a:prstGeom prst="rect">
+            <a:avLst/>
+          </a:prstGeom>
+          <a:noFill/>
+          <a:ln/>
+        </p:spPr>
+        <p:txBody>
+          <a:bodyPr wrap="square" rtlCol="0" anchor="ctr"/>
+          <a:lstStyle/>
+          <a:p>
+            <a:pPr algn="ctr" indent="0" marL="0">
+              <a:buNone/>
+            </a:pPr>
+            <a:r>
+              <a:rPr lang="en-US" sz="950" b="1" spc="100" kern="0" dirty="0">
+                <a:solidFill>
+                  <a:srgbClr val="9A7C5C"/>
+                </a:solidFill>
+                <a:latin typeface="Segoe UI" pitchFamily="34" charset="0"/>
+                <a:ea typeface="Segoe UI" pitchFamily="34" charset="-122"/>
+                <a:cs typeface="Segoe UI" pitchFamily="34" charset="-120"/>
+              </a:rPr>
+              <a:t>ÉVOLUTIONS RÉCENTES — KOJI PRO (OCTOBRE 2026)</a:t>
+            </a:r>
+            <a:endParaRPr lang="en-US" sz="950" dirty="0"/>
+          </a:p>
+        </p:txBody>
+      </p:sp>
+      <p:sp>
+        <p:nvSpPr>
+          <p:cNvPr id="4" name="Shape 2"/>
+          <p:cNvSpPr/>
+          <p:nvPr/>
+        </p:nvSpPr>
+        <p:spPr>
+          <a:xfrm>
+            <a:off x="640080" y="1005840"/>
+            <a:ext cx="10881360" cy="1737360"/>
+          </a:xfrm>
+          <a:prstGeom prst="roundRect">
+            <a:avLst>
+              <a:gd name="adj" fmla="val 3158"/>
+            </a:avLst>
+          </a:prstGeom>
+          <a:solidFill>
+            <a:srgbClr val="FFFFFF"/>
+          </a:solidFill>
+          <a:ln w="12700">
+            <a:solidFill>
+              <a:srgbClr val="E4DCCB"/>
+            </a:solidFill>
+            <a:prstDash val="solid"/>
+          </a:ln>
+        </p:spPr>
+      </p:sp>
+      <p:sp>
+        <p:nvSpPr>
+          <p:cNvPr id="5" name="Shape 3"/>
+          <p:cNvSpPr/>
+          <p:nvPr/>
+        </p:nvSpPr>
+        <p:spPr>
+          <a:xfrm>
+            <a:off x="640080" y="1005840"/>
+            <a:ext cx="54864" cy="1737360"/>
+          </a:xfrm>
+          <a:prstGeom prst="rect">
+            <a:avLst/>
+          </a:prstGeom>
+          <a:solidFill>
+            <a:srgbClr val="1D6FE0"/>
+          </a:solidFill>
+          <a:ln/>
+        </p:spPr>
+      </p:sp>
+      <p:sp>
+        <p:nvSpPr>
+          <p:cNvPr id="6" name="Text 4"/>
+          <p:cNvSpPr/>
+          <p:nvPr/>
+        </p:nvSpPr>
+        <p:spPr>
+          <a:xfrm>
+            <a:off x="914400" y="1133856"/>
+            <a:ext cx="10332720" cy="365760"/>
+          </a:xfrm>
+          <a:prstGeom prst="rect">
+            <a:avLst/>
+          </a:prstGeom>
+          <a:noFill/>
+          <a:ln/>
+        </p:spPr>
+        <p:txBody>
+          <a:bodyPr wrap="square" rtlCol="0" anchor="ctr"/>
+          <a:lstStyle/>
+          <a:p>
+            <a:pPr indent="0" marL="0">
+              <a:buNone/>
+            </a:pPr>
+            <a:r>
+              <a:rPr lang="en-US" sz="1500" b="1" dirty="0">
+                <a:solidFill>
+                  <a:srgbClr val="1B1F3B"/>
+                </a:solidFill>
+                <a:latin typeface="Georgia" pitchFamily="34" charset="0"/>
+                <a:ea typeface="Georgia" pitchFamily="34" charset="-122"/>
+                <a:cs typeface="Georgia" pitchFamily="34" charset="-120"/>
+              </a:rPr>
+              <a:t>Validation et tests de la refonte Koji Pro</a:t>
+            </a:r>
+            <a:endParaRPr lang="en-US" sz="1500" dirty="0"/>
+          </a:p>
+        </p:txBody>
+      </p:sp>
+      <p:sp>
+        <p:nvSpPr>
+          <p:cNvPr id="7" name="Text 5"/>
+          <p:cNvSpPr/>
+          <p:nvPr/>
+        </p:nvSpPr>
+        <p:spPr>
+          <a:xfrm>
+            <a:off x="914400" y="1536192"/>
+            <a:ext cx="10332720" cy="1005840"/>
+          </a:xfrm>
+          <a:prstGeom prst="rect">
+            <a:avLst/>
+          </a:prstGeom>
+          <a:noFill/>
+          <a:ln/>
+        </p:spPr>
+        <p:txBody>
+          <a:bodyPr wrap="square" rtlCol="0" anchor="ctr"/>
+          <a:lstStyle/>
+          <a:p>
+            <a:pPr indent="0" marL="0">
+              <a:lnSpc>
+                <a:spcPts val="1600"/>
+              </a:lnSpc>
+              <a:buNone/>
+            </a:pPr>
+            <a:r>
+              <a:rPr lang="en-US" sz="1150" dirty="0">
+                <a:solidFill>
+                  <a:srgbClr val="1B1F3B"/>
+                </a:solidFill>
+                <a:latin typeface="Segoe UI" pitchFamily="34" charset="0"/>
+                <a:ea typeface="Segoe UI" pitchFamily="34" charset="-122"/>
+                <a:cs typeface="Segoe UI" pitchFamily="34" charset="-120"/>
+              </a:rPr>
+              <a:t>Tests Playwright pour le web : 16/16 pages PRO passent les validations (sélecteurs CSS, KPIs, listes, formulaires). Tests Flutter : 0 erreurs de compilation (flutter analyze). Tous les composants respectent la DA et les spécifications PRO-01 à PRO-17.</a:t>
+            </a:r>
+            <a:endParaRPr lang="en-US" sz="1150" dirty="0"/>
+          </a:p>
+        </p:txBody>
+      </p:sp>
+      <p:sp>
+        <p:nvSpPr>
+          <p:cNvPr id="8" name="Text 6"/>
+          <p:cNvSpPr/>
+          <p:nvPr/>
+        </p:nvSpPr>
+        <p:spPr>
+          <a:xfrm>
+            <a:off x="365760" y="6510528"/>
+            <a:ext cx="5486400" cy="274320"/>
+          </a:xfrm>
+          <a:prstGeom prst="rect">
+            <a:avLst/>
+          </a:prstGeom>
+          <a:noFill/>
+          <a:ln/>
+        </p:spPr>
+        <p:txBody>
+          <a:bodyPr wrap="square" rtlCol="0" anchor="ctr"/>
+          <a:lstStyle/>
+          <a:p>
+            <a:pPr indent="0" marL="0">
+              <a:buNone/>
+            </a:pPr>
+            <a:r>
+              <a:rPr lang="en-US" sz="850" dirty="0">
+                <a:solidFill>
+                  <a:srgbClr val="8A7C68"/>
+                </a:solidFill>
+                <a:latin typeface="Segoe UI" pitchFamily="34" charset="0"/>
+                <a:ea typeface="Segoe UI" pitchFamily="34" charset="-122"/>
+                <a:cs typeface="Segoe UI" pitchFamily="34" charset="-120"/>
+              </a:rPr>
+              <a:t>Koji Web — Cahier des charges</a:t>
+            </a:r>
+            <a:endParaRPr lang="en-US" sz="850" dirty="0"/>
+          </a:p>
+        </p:txBody>
+      </p:sp>
+      <p:sp>
+        <p:nvSpPr>
+          <p:cNvPr id="9" name="Text 7"/>
+          <p:cNvSpPr/>
+          <p:nvPr/>
+        </p:nvSpPr>
+        <p:spPr>
+          <a:xfrm>
+            <a:off x="9601200" y="6510528"/>
+            <a:ext cx="2194560" cy="274320"/>
+          </a:xfrm>
+          <a:prstGeom prst="rect">
+            <a:avLst/>
+          </a:prstGeom>
+          <a:noFill/>
+          <a:ln/>
+        </p:spPr>
+        <p:txBody>
+          <a:bodyPr wrap="square" rtlCol="0" anchor="ctr"/>
+          <a:lstStyle/>
+          <a:p>
+            <a:pPr algn="r" indent="0" marL="0">
+              <a:buNone/>
+            </a:pPr>
+            <a:r>
+              <a:rPr lang="en-US" sz="850" dirty="0">
+                <a:solidFill>
+                  <a:srgbClr val="8A7C68"/>
+                </a:solidFill>
+                <a:latin typeface="Segoe UI" pitchFamily="34" charset="0"/>
+                <a:ea typeface="Segoe UI" pitchFamily="34" charset="-122"/>
+                <a:cs typeface="Segoe UI" pitchFamily="34" charset="-120"/>
+              </a:rPr>
+              <a:t>92</a:t>
+            </a:r>
+            <a:endParaRPr lang="en-US" sz="850" dirty="0"/>
+          </a:p>
+        </p:txBody>
+      </p:sp>
+    </p:spTree>
+  </p:cSld>
+  <p:clrMapOvr>
+    <a:masterClrMapping/>
+  </p:clrMapOvr>
+</p:sld>
+</file>
+
+<file path=ppt/slides/slide94.xml><?xml version="1.0" encoding="utf-8"?>
+<p:sld xmlns:a="http://schemas.openxmlformats.org/drawingml/2006/main" xmlns:r="http://schemas.openxmlformats.org/officeDocument/2006/relationships" xmlns:p="http://schemas.openxmlformats.org/presentationml/2006/main">
+  <p:cSld name="Slide 94">
     <p:bg>
       <p:bgPr>
         <a:solidFill>

</xml_diff>